<commit_message>
add graphs and configs to slides
</commit_message>
<xml_diff>
--- a/Federico_Cristofaro_ML-2025_slides.pptx
+++ b/Federico_Cristofaro_ML-2025_slides.pptx
@@ -28,10 +28,9 @@
     <p:sldId id="276" r:id="rId22"/>
     <p:sldId id="277" r:id="rId23"/>
     <p:sldId id="278" r:id="rId24"/>
-    <p:sldId id="279" r:id="rId25"/>
   </p:sldIdLst>
   <p:notesMasterIdLst>
-    <p:notesMasterId r:id="rId26"/>
+    <p:notesMasterId r:id="rId25"/>
   </p:notesMasterIdLst>
   <p:sldSz cx="9144000" cy="5143500"/>
   <p:notesSz cx="5143500" cy="9144000"/>
@@ -130,27 +129,27 @@
   <p:extLst>
     <p:ext uri="{521415D9-36F7-43E2-AB2F-B90AF26B5E84}">
       <p14:sectionLst xmlns:p14="http://schemas.microsoft.com/office/powerpoint/2010/main">
-        <p14:section name="Introduction" id="{096192f6-5c30-33ba-9494-5caef97f01ae}">
+        <p14:section name="Introduction" id="{10f5c6cc-b3b5-64f2-73ff-67a632b6ddd4}">
           <p14:sldIdLst>
             <p14:sldId id="256"/>
             <p14:sldId id="257"/>
           </p14:sldIdLst>
         </p14:section>
-        <p14:section name="Method" id="{48ce60eb-3e7a-d9f9-474d-8bd4c7fec8e8}">
+        <p14:section name="Method" id="{6d54a8f6-da7c-4e2b-ad06-540a5ec008d3}">
           <p14:sldIdLst>
             <p14:sldId id="258"/>
             <p14:sldId id="259"/>
             <p14:sldId id="260"/>
           </p14:sldIdLst>
         </p14:section>
-        <p14:section name="MONK" id="{185c0ed8-0c09-f8ff-d061-0befd8bbf397}">
+        <p14:section name="MONK" id="{fa4e4aa2-a0c2-5a8a-f634-6638723d4565}">
           <p14:sldIdLst>
             <p14:sldId id="261"/>
             <p14:sldId id="262"/>
             <p14:sldId id="263"/>
           </p14:sldIdLst>
         </p14:section>
-        <p14:section name="CUP" id="{c80f64a1-7d00-b343-8058-83d1dd4ef1c5}">
+        <p14:section name="CUP" id="{a05e2619-5ada-cd9e-3bee-a14c560f48ff}">
           <p14:sldIdLst>
             <p14:sldId id="264"/>
             <p14:sldId id="265"/>
@@ -160,26 +159,25 @@
             <p14:sldId id="269"/>
           </p14:sldIdLst>
         </p14:section>
-        <p14:section name="Discussion" id="{536a3791-866d-cbac-a240-29da18ae4609}">
+        <p14:section name="Discussion" id="{9b19a13a-d0d2-8fde-d192-27d0b3c9dd18}">
           <p14:sldIdLst>
             <p14:sldId id="270"/>
             <p14:sldId id="271"/>
             <p14:sldId id="272"/>
           </p14:sldIdLst>
         </p14:section>
-        <p14:section name="References" id="{619f0a22-db8c-f654-4b85-6cb4615f6b20}">
+        <p14:section name="References" id="{8ab5f447-4525-0af0-14c5-fcfc46fb3864}">
           <p14:sldIdLst>
             <p14:sldId id="273"/>
           </p14:sldIdLst>
         </p14:section>
-        <p14:section name="Appendix" id="{6729c037-55b5-8b99-cda3-aa9acc21b915}">
+        <p14:section name="Appendix" id="{4910d943-bd35-17a8-365e-3e48922bcb7e}">
           <p14:sldIdLst>
             <p14:sldId id="274"/>
             <p14:sldId id="275"/>
             <p14:sldId id="276"/>
             <p14:sldId id="277"/>
             <p14:sldId id="278"/>
-            <p14:sldId id="279"/>
           </p14:sldIdLst>
         </p14:section>
       </p14:sectionLst>
@@ -675,7 +673,7 @@
             <a:r>
               <a:rPr lang="en-US" dirty="0"/>
               <a:t>[*] Schema and range of the explored hyper-parameters. Single or multi-stage / nested grid? How many configurations in total?
-The fine-grid column is a draft from configs/cup/cup_single_try_2.json: replace with the real final grid.
+Fine grid from configs/cup/cup_grid_fine.json (tag cup-grid-fine-final, seed 42). The earlier stages are still to be listed.
 The complete setting goes in the Appendix (A.1) and in a 'hyperparameters-setting' file in the code package.</a:t>
             </a:r>
             <a:endParaRPr lang="en-US" dirty="0"/>
@@ -945,7 +943,8 @@
               <a:t>[*] How the FINAL model was selected, which candidate and why, its hyper-parameters, and how the initialization for the blind test was chosen.
 [*][*] Table with MEE for TR, VL and internal TS in the original scale. VL comes from the model selection (CV mean).
 The course asks the criterion that sets up the final network among the possible initializations: e.g. a seed fixed in advance. Never pick it by internal test MEE.
-Training time and machine are mandatory: the runs are on Gabriele's machine, he fills in the hardware and times.</a:t>
+Training time and machine are mandatory: the runs are on Gabriele's machine (env in configs/final/CUP_config.json: Python 3.14.6, NumPy 2.5.0, Intel family 6 model 186), he fills in the exact CPU, RAM and times.
+TR is the CV target by construction (every retraining stops there). VL: mean ± std of the chosen row of the fine grid.</a:t>
             </a:r>
             <a:endParaRPr lang="en-US" dirty="0"/>
           </a:p>
@@ -1034,7 +1033,8 @@
             <a:r>
               <a:rPr lang="en-US" dirty="0"/>
               <a:t>[*] Learning curve TR / (VL) / TS of the FINAL model (it is unique). The VL curve may be missing if the retraining uses all the design data.
-The test curve is only recorded: it never decides when to stop (say it explicitly if asked).</a:t>
+The test curve is only recorded: it never decides when to stop (say it explicitly if asked).
+The blind-test network is fitted on all 500 rows and has no test curve: this is one of the 30 assessment retrainings, with the same hyper-parameters and stopping rule.</a:t>
             </a:r>
             <a:endParaRPr lang="en-US" dirty="0"/>
           </a:p>
@@ -1960,94 +1960,6 @@
 </p:notes>
 </file>
 
-<file path=ppt/notesSlides/notesSlide24.xml><?xml version="1.0" encoding="utf-8"?>
-<p:notes xmlns:a="http://schemas.openxmlformats.org/drawingml/2006/main" xmlns:r="http://schemas.openxmlformats.org/officeDocument/2006/relationships" xmlns:p="http://schemas.openxmlformats.org/presentationml/2006/main">
-  <p:cSld>
-    <p:spTree>
-      <p:nvGrpSpPr>
-        <p:cNvPr id="1" name=""/>
-        <p:cNvGrpSpPr/>
-        <p:nvPr/>
-      </p:nvGrpSpPr>
-      <p:grpSpPr>
-        <a:xfrm>
-          <a:off x="0" y="0"/>
-          <a:ext cx="0" cy="0"/>
-          <a:chOff x="0" y="0"/>
-          <a:chExt cx="0" cy="0"/>
-        </a:xfrm>
-      </p:grpSpPr>
-      <p:sp>
-        <p:nvSpPr>
-          <p:cNvPr id="2" name="Slide Image Placeholder 1"/>
-          <p:cNvSpPr>
-            <a:spLocks noGrp="1" noRot="1" noChangeAspect="1"/>
-          </p:cNvSpPr>
-          <p:nvPr>
-            <p:ph type="sldImg"/>
-          </p:nvPr>
-        </p:nvSpPr>
-        <p:spPr/>
-      </p:sp>
-      <p:sp>
-        <p:nvSpPr>
-          <p:cNvPr id="3" name="Notes Placeholder 2"/>
-          <p:cNvSpPr>
-            <a:spLocks noGrp="1"/>
-          </p:cNvSpPr>
-          <p:nvPr>
-            <p:ph type="body" idx="1"/>
-          </p:nvPr>
-        </p:nvSpPr>
-        <p:spPr/>
-        <p:txBody>
-          <a:bodyPr/>
-          <a:lstStyle/>
-          <a:p>
-            <a:r>
-              <a:rPr lang="en-US" dirty="0"/>
-              <a:t/>
-            </a:r>
-            <a:endParaRPr lang="en-US" dirty="0"/>
-          </a:p>
-        </p:txBody>
-      </p:sp>
-      <p:sp>
-        <p:nvSpPr>
-          <p:cNvPr id="4" name="Slide Number Placeholder 3"/>
-          <p:cNvSpPr>
-            <a:spLocks noGrp="1"/>
-          </p:cNvSpPr>
-          <p:nvPr>
-            <p:ph type="sldNum" sz="quarter" idx="10"/>
-          </p:nvPr>
-        </p:nvSpPr>
-        <p:spPr/>
-        <p:txBody>
-          <a:bodyPr/>
-          <a:lstStyle/>
-          <a:p>
-            <a:fld id="{F7021451-1387-4CA6-816F-3879F97B5CBC}" type="slidenum">
-              <a:rPr lang="en-US"/>
-              <a:t>24</a:t>
-            </a:fld>
-            <a:endParaRPr lang="en-US"/>
-          </a:p>
-        </p:txBody>
-      </p:sp>
-    </p:spTree>
-    <p:extLst>
-      <p:ext uri="{BB962C8B-B14F-4D97-AF65-F5344CB8AC3E}">
-        <p14:creationId xmlns:p14="http://schemas.microsoft.com/office/powerpoint/2010/main" val="1024086991"/>
-      </p:ext>
-    </p:extLst>
-  </p:cSld>
-  <p:clrMapOvr>
-    <a:masterClrMapping/>
-  </p:clrMapOvr>
-</p:notes>
-</file>
-
 <file path=ppt/notesSlides/notesSlide3.xml><?xml version="1.0" encoding="utf-8"?>
 <p:notes xmlns:a="http://schemas.openxmlformats.org/drawingml/2006/main" xmlns:r="http://schemas.openxmlformats.org/officeDocument/2006/relationships" xmlns:p="http://schemas.openxmlformats.org/presentationml/2006/main">
   <p:cSld>
@@ -2362,8 +2274,9 @@
             <a:r>
               <a:rPr lang="en-US" dirty="0"/>
               <a:t>[*] Lack of results here invalidates the report. Report the MEAN over the initializations, not the best one; MSE without penalty.
-MONK 3 needs a second row with regularization. Use the course notation (η, α, λ), not library names.
-The hyper-parameters in the table come from configs/monk*/monk*_assess*.json: verify they are the final ones.</a:t>
+Values are read at build time from results/final/*_summary.json and configs/final/*_config.json.
+MONK 2 without L2: the fine grid (configs/monk2/monk2_grid_fine_s2026.json) ranks no-penalty configurations first; the earlier λ 5e-4 run (99.6 ± 1.2% TS) is kept as results/final/MONK2_l2_*.
+MONK 3 (reg.): a hold-out grid could not separate the configurations (top 9 within one validation pattern) and its pick, λ 1e-3, gave 95.1% TS; 5-fold CV ranks λ 0.01 first in all top 8 configurations.</a:t>
             </a:r>
             <a:endParaRPr lang="en-US" dirty="0"/>
           </a:p>
@@ -2452,7 +2365,7 @@
             <a:r>
               <a:rPr lang="en-US" dirty="0"/>
               <a:t>[*] MSE and accuracy plots for each MONK. Readable in black and white (different line styles), large fonts for legend and axes, one point per epoch (mean over the epoch for mini-batch).
-Source: learning_curve.png of the assess runs in results/monk*/.</a:t>
+Source: results/final/MONK*_learning_curve.png.</a:t>
             </a:r>
             <a:endParaRPr lang="en-US" dirty="0"/>
           </a:p>
@@ -2540,7 +2453,8 @@
           <a:p>
             <a:r>
               <a:rPr lang="en-US" dirty="0"/>
-              <a:t>MONK 3 has noisy labels: show the effect of regularization on overfitting (TR vs TS).</a:t>
+              <a:t>MONK 3: the training set has 5% misclassified examples [2], so TR accuracy stays below 100%.
+Without L2 the TS accuracy of the representative trial peaks near 97% around epoch 70 and ends at 95.6%. With λ 0.01 the network keeps TR at 93.4% and TS at 97.1% (97.2% in 42 of 50 trials). 8 trials never reach the TR-MSE target (they settle at 0.082 because of the penalty) and stop at 1000 epochs, still at 97.2% TS.</a:t>
             </a:r>
             <a:endParaRPr lang="en-US" dirty="0"/>
           </a:p>
@@ -2630,7 +2544,8 @@
               <a:rPr lang="en-US" dirty="0"/>
               <a:t>[*] Validation schema: splitting TR / VL / internal TS with percentages and K. Answer the template question: is there a final retraining?
 Split and seeds from the code: internal test 20% with seed 0, the same in every run (src/data/cup.py).
-Verify that the final retraining really uses the CV TR-error target (cv_stop_target in the assess config).</a:t>
+k = 3 and 10 inits come from configs/cup/cup_grid_fine.json: confirm with the select run.
+Final model (experiments/cup_final.py): seeds of assessment trial 0, fixed before looking at the test; fitted on all 500 labelled rows and stopped at the same cv_stop_target.</a:t>
             </a:r>
             <a:endParaRPr lang="en-US" dirty="0"/>
           </a:p>
@@ -4139,7 +4054,7 @@
                   <a:schemeClr val="bg1"/>
                 </a:solidFill>
               </a:rPr>
-              <a:t>[N] configs</a:t>
+              <a:t>60 configs</a:t>
             </a:r>
             <a:endParaRPr lang="en-US" sz="1400" dirty="0"/>
           </a:p>
@@ -4175,7 +4090,7 @@
                   <a:schemeClr val="tx1"/>
                 </a:solidFill>
               </a:rPr>
-              <a:t>Per configuration: 5 folds × </a:t>
+              <a:t>Fine grid: </a:t>
             </a:r>
             <a:pPr indent="0" marL="0">
               <a:buNone/>
@@ -4186,7 +4101,7 @@
                   <a:schemeClr val="accent2"/>
                 </a:solidFill>
               </a:rPr>
-              <a:t>[5]</a:t>
+              <a:t>3</a:t>
             </a:r>
             <a:pPr indent="0" marL="0">
               <a:buNone/>
@@ -4197,7 +4112,29 @@
                   <a:schemeClr val="tx1"/>
                 </a:solidFill>
               </a:rPr>
-              <a:t> inits; ranking by mean VL MEE, ties by VL loss</a:t>
+              <a:t> folds × </a:t>
+            </a:r>
+            <a:pPr indent="0" marL="0">
+              <a:buNone/>
+            </a:pPr>
+            <a:r>
+              <a:rPr lang="en-US" sz="1400" i="1" dirty="0">
+                <a:solidFill>
+                  <a:schemeClr val="accent2"/>
+                </a:solidFill>
+              </a:rPr>
+              <a:t>10</a:t>
+            </a:r>
+            <a:pPr indent="0" marL="0">
+              <a:buNone/>
+            </a:pPr>
+            <a:r>
+              <a:rPr lang="en-US" sz="1400" dirty="0">
+                <a:solidFill>
+                  <a:schemeClr val="tx1"/>
+                </a:solidFill>
+              </a:rPr>
+              <a:t> inits per configuration; ranking by mean VL MEE, ties by VL loss</a:t>
             </a:r>
             <a:endParaRPr lang="en-US" sz="1400" dirty="0"/>
           </a:p>
@@ -4262,9 +4199,9 @@
             <a:tbl>
               <a:tblPr/>
               <a:tblGrid>
-                <a:gridCol w="2103120"/>
-                <a:gridCol w="1783080"/>
-                <a:gridCol w="1783080"/>
+                <a:gridCol w="1965960"/>
+                <a:gridCol w="1325880"/>
+                <a:gridCol w="2377440"/>
               </a:tblGrid>
               <a:tr h="365760">
                 <a:tc>
@@ -4583,12 +4520,12 @@
                         <a:buNone/>
                       </a:pPr>
                       <a:r>
-                        <a:rPr lang="en-US" sz="1400" i="1" dirty="0">
+                        <a:rPr lang="en-US" sz="1400" dirty="0">
                           <a:solidFill>
-                            <a:schemeClr val="accent2"/>
+                            <a:schemeClr val="tx1"/>
                           </a:solidFill>
                         </a:rPr>
-                        <a:t>64-64-32</a:t>
+                        <a:t>64-64</a:t>
                       </a:r>
                       <a:endParaRPr lang="en-US" sz="1400" dirty="0"/>
                     </a:p>
@@ -4768,9 +4705,9 @@
                         <a:buNone/>
                       </a:pPr>
                       <a:r>
-                        <a:rPr lang="en-US" sz="1400" i="1" dirty="0">
+                        <a:rPr lang="en-US" sz="1400" dirty="0">
                           <a:solidFill>
-                            <a:schemeClr val="accent2"/>
+                            <a:schemeClr val="tx1"/>
                           </a:solidFill>
                         </a:rPr>
                         <a:t>ReLU / He</a:t>
@@ -4836,7 +4773,7 @@
                             <a:schemeClr val="tx1"/>
                           </a:solidFill>
                         </a:rPr>
-                        <a:t>η, schedule</a:t>
+                        <a:t>η (fixed)</a:t>
                       </a:r>
                       <a:endParaRPr lang="en-US" sz="1400" dirty="0"/>
                     </a:p>
@@ -4953,12 +4890,12 @@
                         <a:buNone/>
                       </a:pPr>
                       <a:r>
-                        <a:rPr lang="en-US" sz="1400" i="1" dirty="0">
+                        <a:rPr lang="en-US" sz="1400" dirty="0">
                           <a:solidFill>
-                            <a:schemeClr val="accent2"/>
+                            <a:schemeClr val="tx1"/>
                           </a:solidFill>
                         </a:rPr>
-                        <a:t>0.005, 0.01; fixed</a:t>
+                        <a:t>0.009, 0.01, 0.011</a:t>
                       </a:r>
                       <a:endParaRPr lang="en-US" sz="1400" dirty="0"/>
                     </a:p>
@@ -5021,7 +4958,7 @@
                             <a:schemeClr val="tx1"/>
                           </a:solidFill>
                         </a:rPr>
-                        <a:t>α, momentum type</a:t>
+                        <a:t>α (classical momentum)</a:t>
                       </a:r>
                       <a:endParaRPr lang="en-US" sz="1400" dirty="0"/>
                     </a:p>
@@ -5138,12 +5075,12 @@
                         <a:buNone/>
                       </a:pPr>
                       <a:r>
-                        <a:rPr lang="en-US" sz="1400" i="1" dirty="0">
+                        <a:rPr lang="en-US" sz="1400" dirty="0">
                           <a:solidFill>
-                            <a:schemeClr val="accent2"/>
+                            <a:schemeClr val="tx1"/>
                           </a:solidFill>
                         </a:rPr>
-                        <a:t>0.75, 0.9; Nesterov</a:t>
+                        <a:t>0, 0.75, 0.85, 0.88, 0.9</a:t>
                       </a:r>
                       <a:endParaRPr lang="en-US" sz="1400" dirty="0"/>
                     </a:p>
@@ -5206,7 +5143,7 @@
                             <a:schemeClr val="tx1"/>
                           </a:solidFill>
                         </a:rPr>
-                        <a:t>Regularization, λ</a:t>
+                        <a:t>λ (L2)</a:t>
                       </a:r>
                       <a:endParaRPr lang="en-US" sz="1400" dirty="0"/>
                     </a:p>
@@ -5323,12 +5260,12 @@
                         <a:buNone/>
                       </a:pPr>
                       <a:r>
-                        <a:rPr lang="en-US" sz="1400" i="1" dirty="0">
+                        <a:rPr lang="en-US" sz="1400" dirty="0">
                           <a:solidFill>
-                            <a:schemeClr val="accent2"/>
+                            <a:schemeClr val="tx1"/>
                           </a:solidFill>
                         </a:rPr>
-                        <a:t>L2: 0.005, 0.0075, 0.01</a:t>
+                        <a:t>none, 0.008, 0.009, 0.01</a:t>
                       </a:r>
                       <a:endParaRPr lang="en-US" sz="1400" dirty="0"/>
                     </a:p>
@@ -5391,7 +5328,7 @@
                             <a:schemeClr val="tx1"/>
                           </a:solidFill>
                         </a:rPr>
-                        <a:t>Mini-batch size</a:t>
+                        <a:t>Batch</a:t>
                       </a:r>
                       <a:endParaRPr lang="en-US" sz="1400" dirty="0"/>
                     </a:p>
@@ -5508,12 +5445,12 @@
                         <a:buNone/>
                       </a:pPr>
                       <a:r>
-                        <a:rPr lang="en-US" sz="1400" i="1" dirty="0">
+                        <a:rPr lang="en-US" sz="1400" dirty="0">
                           <a:solidFill>
-                            <a:schemeClr val="accent2"/>
+                            <a:schemeClr val="tx1"/>
                           </a:solidFill>
                         </a:rPr>
-                        <a:t>32</a:t>
+                        <a:t>full batch</a:t>
                       </a:r>
                       <a:endParaRPr lang="en-US" sz="1400" dirty="0"/>
                     </a:p>
@@ -5693,12 +5630,12 @@
                         <a:buNone/>
                       </a:pPr>
                       <a:r>
-                        <a:rPr lang="en-US" sz="1400" i="1" dirty="0">
+                        <a:rPr lang="en-US" sz="1400" dirty="0">
                           <a:solidFill>
-                            <a:schemeClr val="accent2"/>
+                            <a:schemeClr val="tx1"/>
                           </a:solidFill>
                         </a:rPr>
-                        <a:t>5000 / 500</a:t>
+                        <a:t>2000 / 100</a:t>
                       </a:r>
                       <a:endParaRPr lang="en-US" sz="1400" dirty="0"/>
                     </a:p>
@@ -5949,7 +5886,7 @@
                   <a:schemeClr val="accent3"/>
                 </a:solidFill>
               </a:rPr>
-              <a:t>Fig. 3. </a:t>
+              <a:t>Fig. 5. </a:t>
             </a:r>
             <a:pPr indent="0" marL="0">
               <a:buNone/>
@@ -6380,7 +6317,7 @@
                   <a:schemeClr val="accent3"/>
                 </a:solidFill>
               </a:rPr>
-              <a:t>Table 3. Top-5 configurations of the fine grid: MEE (original scale), mean ± std over 5 folds × </a:t>
+              <a:t>Table 3. Top-5 configurations of the fine grid: MEE (original scale), mean ± std over </a:t>
             </a:r>
             <a:pPr indent="0" marL="0">
               <a:buNone/>
@@ -6391,7 +6328,29 @@
                   <a:schemeClr val="accent2"/>
                 </a:solidFill>
               </a:rPr>
-              <a:t>[5]</a:t>
+              <a:t>3</a:t>
+            </a:r>
+            <a:pPr indent="0" marL="0">
+              <a:buNone/>
+            </a:pPr>
+            <a:r>
+              <a:rPr lang="en-US" sz="1400" i="1" dirty="0">
+                <a:solidFill>
+                  <a:schemeClr val="accent3"/>
+                </a:solidFill>
+              </a:rPr>
+              <a:t> folds × </a:t>
+            </a:r>
+            <a:pPr indent="0" marL="0">
+              <a:buNone/>
+            </a:pPr>
+            <a:r>
+              <a:rPr lang="en-US" sz="1400" i="1" dirty="0">
+                <a:solidFill>
+                  <a:schemeClr val="accent2"/>
+                </a:solidFill>
+              </a:rPr>
+              <a:t>10</a:t>
             </a:r>
             <a:pPr indent="0" marL="0">
               <a:buNone/>
@@ -10063,23 +10022,12 @@
               <a:buChar char="•"/>
             </a:pPr>
             <a:r>
-              <a:rPr lang="en-US" sz="1400" i="1" dirty="0">
-                <a:solidFill>
-                  <a:schemeClr val="accent2"/>
-                </a:solidFill>
-              </a:rPr>
-              <a:t>[64-64-32]</a:t>
-            </a:r>
-            <a:pPr indent="0" marL="0">
-              <a:buNone/>
-            </a:pPr>
-            <a:r>
               <a:rPr lang="en-US" sz="1400" dirty="0">
                 <a:solidFill>
                   <a:schemeClr val="tx1"/>
                 </a:solidFill>
               </a:rPr>
-              <a:t> ReLU, 4 linear outputs, He init</a:t>
+              <a:t>12-64-64-4: ReLU hidden, linear outputs, He init</a:t>
             </a:r>
             <a:endParaRPr lang="en-US" sz="1400" dirty="0"/>
           </a:p>
@@ -10097,84 +10045,7 @@
                   <a:schemeClr val="tx1"/>
                 </a:solidFill>
               </a:rPr>
-              <a:t>SGD η </a:t>
-            </a:r>
-            <a:pPr indent="0" marL="0">
-              <a:buNone/>
-            </a:pPr>
-            <a:r>
-              <a:rPr lang="en-US" sz="1400" i="1" dirty="0">
-                <a:solidFill>
-                  <a:schemeClr val="accent2"/>
-                </a:solidFill>
-              </a:rPr>
-              <a:t>[…]</a:t>
-            </a:r>
-            <a:pPr indent="0" marL="0">
-              <a:buNone/>
-            </a:pPr>
-            <a:r>
-              <a:rPr lang="en-US" sz="1400" dirty="0">
-                <a:solidFill>
-                  <a:schemeClr val="tx1"/>
-                </a:solidFill>
-              </a:rPr>
-              <a:t>, α </a:t>
-            </a:r>
-            <a:pPr indent="0" marL="0">
-              <a:buNone/>
-            </a:pPr>
-            <a:r>
-              <a:rPr lang="en-US" sz="1400" i="1" dirty="0">
-                <a:solidFill>
-                  <a:schemeClr val="accent2"/>
-                </a:solidFill>
-              </a:rPr>
-              <a:t>[…]</a:t>
-            </a:r>
-            <a:pPr indent="0" marL="0">
-              <a:buNone/>
-            </a:pPr>
-            <a:r>
-              <a:rPr lang="en-US" sz="1400" dirty="0">
-                <a:solidFill>
-                  <a:schemeClr val="tx1"/>
-                </a:solidFill>
-              </a:rPr>
-              <a:t> Nesterov, mb </a:t>
-            </a:r>
-            <a:pPr indent="0" marL="0">
-              <a:buNone/>
-            </a:pPr>
-            <a:r>
-              <a:rPr lang="en-US" sz="1400" i="1" dirty="0">
-                <a:solidFill>
-                  <a:schemeClr val="accent2"/>
-                </a:solidFill>
-              </a:rPr>
-              <a:t>[32]</a:t>
-            </a:r>
-            <a:pPr indent="0" marL="0">
-              <a:buNone/>
-            </a:pPr>
-            <a:r>
-              <a:rPr lang="en-US" sz="1400" dirty="0">
-                <a:solidFill>
-                  <a:schemeClr val="tx1"/>
-                </a:solidFill>
-              </a:rPr>
-              <a:t>, L2 λ </a:t>
-            </a:r>
-            <a:pPr indent="0" marL="0">
-              <a:buNone/>
-            </a:pPr>
-            <a:r>
-              <a:rPr lang="en-US" sz="1400" i="1" dirty="0">
-                <a:solidFill>
-                  <a:schemeClr val="accent2"/>
-                </a:solidFill>
-              </a:rPr>
-              <a:t>[…]</a:t>
+              <a:t>SGD η 0.01, α 0.9 (classical), full batch, L2 λ 0.01</a:t>
             </a:r>
             <a:endParaRPr lang="en-US" sz="1400" dirty="0"/>
           </a:p>
@@ -10192,21 +10063,17 @@
                   <a:schemeClr val="tx1"/>
                 </a:solidFill>
               </a:rPr>
-              <a:t>Blind test: one network retrained with seed </a:t>
-            </a:r>
-            <a:pPr indent="0" marL="0">
-              <a:buNone/>
-            </a:pPr>
-            <a:r>
-              <a:rPr lang="en-US" sz="1400" i="1" dirty="0">
-                <a:solidFill>
-                  <a:schemeClr val="accent2"/>
-                </a:solidFill>
-              </a:rPr>
-              <a:t>[s]</a:t>
-            </a:r>
-            <a:pPr indent="0" marL="0">
-              <a:buNone/>
+              <a:t>Stops at TR MEE 16.69 (CV target), 2597-4828 epochs</a:t>
+            </a:r>
+            <a:endParaRPr lang="en-US" sz="1400" dirty="0"/>
+          </a:p>
+          <a:p>
+            <a:pPr marL="177800" indent="-177800">
+              <a:spcAft>
+                <a:spcPts val="700"/>
+              </a:spcAft>
+              <a:buSzPct val="100000"/>
+              <a:buChar char="•"/>
             </a:pPr>
             <a:r>
               <a:rPr lang="en-US" sz="1400" dirty="0">
@@ -10214,18 +10081,7 @@
                   <a:schemeClr val="tx1"/>
                 </a:solidFill>
               </a:rPr>
-              <a:t>, </a:t>
-            </a:r>
-            <a:pPr indent="0" marL="0">
-              <a:buNone/>
-            </a:pPr>
-            <a:r>
-              <a:rPr lang="en-US" sz="1400" i="1" dirty="0">
-                <a:solidFill>
-                  <a:schemeClr val="accent2"/>
-                </a:solidFill>
-              </a:rPr>
-              <a:t>[why this initialization]</a:t>
+              <a:t>Blind test: trial-0 seeds (fixed in advance), refit on all 500 patterns</a:t>
             </a:r>
             <a:endParaRPr lang="en-US" sz="1400" dirty="0"/>
           </a:p>
@@ -10239,8 +10095,8 @@
         </p:nvSpPr>
         <p:spPr>
           <a:xfrm>
-            <a:off x="4709160" y="960120"/>
-            <a:ext cx="3977640" cy="320040"/>
+            <a:off x="4709160" y="914400"/>
+            <a:ext cx="3977640" cy="749808"/>
           </a:xfrm>
           <a:prstGeom prst="rect">
             <a:avLst/>
@@ -10261,7 +10117,7 @@
                   <a:schemeClr val="accent3"/>
                 </a:solidFill>
               </a:rPr>
-              <a:t>Table 4. Final model MEE, original scale.</a:t>
+              <a:t>Table 4. MEE, original scale: mean ± std over 30 retrainings; VL from the model selection.</a:t>
             </a:r>
             <a:endParaRPr lang="en-US" sz="1400" dirty="0"/>
           </a:p>
@@ -10282,7 +10138,7 @@
           </p:nvPr>
         </p:nvGraphicFramePr>
         <p:xfrm>
-          <a:off x="4709160" y="1298448"/>
+          <a:off x="4709160" y="1691640"/>
           <a:ext cx="3977640" cy="914400"/>
         </p:xfrm>
         <a:graphic>
@@ -10611,12 +10467,12 @@
                         <a:buNone/>
                       </a:pPr>
                       <a:r>
-                        <a:rPr lang="en-US" sz="1400" i="1" dirty="0">
+                        <a:rPr lang="en-US" sz="1400" dirty="0">
                           <a:solidFill>
-                            <a:schemeClr val="accent2"/>
+                            <a:schemeClr val="tx1"/>
                           </a:solidFill>
                         </a:rPr>
-                        <a:t>[…]</a:t>
+                        <a:t>16.69 ± 0.00</a:t>
                       </a:r>
                       <a:endParaRPr lang="en-US" sz="1400" dirty="0"/>
                     </a:p>
@@ -10735,12 +10591,12 @@
                         <a:buNone/>
                       </a:pPr>
                       <a:r>
-                        <a:rPr lang="en-US" sz="1400" dirty="0">
+                        <a:rPr lang="en-US" sz="1400" i="1" dirty="0">
                           <a:solidFill>
-                            <a:schemeClr val="tx1"/>
+                            <a:schemeClr val="accent2"/>
                           </a:solidFill>
                         </a:rPr>
-                        <a:t>5 × 80</a:t>
+                        <a:t>3 × 133</a:t>
                       </a:r>
                       <a:endParaRPr lang="en-US" sz="1400" dirty="0"/>
                     </a:p>
@@ -10981,12 +10837,12 @@
                         <a:buNone/>
                       </a:pPr>
                       <a:r>
-                        <a:rPr lang="en-US" sz="1400" i="1" dirty="0">
+                        <a:rPr lang="en-US" sz="1400" dirty="0">
                           <a:solidFill>
-                            <a:schemeClr val="accent2"/>
+                            <a:schemeClr val="tx1"/>
                           </a:solidFill>
                         </a:rPr>
-                        <a:t>[…]</a:t>
+                        <a:t>20.85 ± 0.29</a:t>
                       </a:r>
                       <a:endParaRPr lang="en-US" sz="1400" dirty="0"/>
                     </a:p>
@@ -11046,12 +10902,12 @@
         </p:nvSpPr>
         <p:spPr>
           <a:xfrm>
-            <a:off x="4709160" y="3063240"/>
-            <a:ext cx="3977640" cy="1508760"/>
+            <a:off x="4709160" y="3246120"/>
+            <a:ext cx="3977640" cy="1325880"/>
           </a:xfrm>
           <a:prstGeom prst="roundRect">
             <a:avLst>
-              <a:gd name="adj" fmla="val 4848"/>
+              <a:gd name="adj" fmla="val 5517"/>
             </a:avLst>
           </a:prstGeom>
           <a:solidFill>
@@ -11068,8 +10924,8 @@
         </p:nvSpPr>
         <p:spPr>
           <a:xfrm>
-            <a:off x="4818888" y="3108960"/>
-            <a:ext cx="3758184" cy="1417320"/>
+            <a:off x="4818888" y="3291840"/>
+            <a:ext cx="3758184" cy="1234440"/>
           </a:xfrm>
           <a:prstGeom prst="rect">
             <a:avLst/>
@@ -11102,12 +10958,23 @@
               <a:buNone/>
             </a:pPr>
             <a:r>
+              <a:rPr lang="en-US" sz="1400" dirty="0">
+                <a:solidFill>
+                  <a:schemeClr val="tx1"/>
+                </a:solidFill>
+              </a:rPr>
+              <a:t>Intel CPU (family 6, model 186), Windows 11, </a:t>
+            </a:r>
+            <a:pPr indent="0" marL="0">
+              <a:buNone/>
+            </a:pPr>
+            <a:r>
               <a:rPr lang="en-US" sz="1400" i="1" dirty="0">
                 <a:solidFill>
                   <a:schemeClr val="accent2"/>
                 </a:solidFill>
               </a:rPr>
-              <a:t>[CPU, cores / threads, RAM]</a:t>
+              <a:t>[model, RAM]</a:t>
             </a:r>
             <a:endParaRPr lang="en-US" sz="1400" dirty="0"/>
           </a:p>
@@ -11132,11 +10999,8 @@
                   <a:schemeClr val="accent2"/>
                 </a:solidFill>
               </a:rPr>
-              <a:t>[N configs × 25 trainings in hh:mm]</a:t>
-            </a:r>
-            <a:endParaRPr lang="en-US" sz="1400" dirty="0"/>
-          </a:p>
-          <a:p>
+              <a:t>[hh:mm]</a:t>
+            </a:r>
             <a:pPr indent="0" marL="0">
               <a:buNone/>
             </a:pPr>
@@ -11146,7 +11010,7 @@
                   <a:schemeClr val="tx1"/>
                 </a:solidFill>
               </a:rPr>
-              <a:t>Final retraining: </a:t>
+              <a:t> · retraining: </a:t>
             </a:r>
             <a:pPr indent="0" marL="0">
               <a:buNone/>
@@ -11157,7 +11021,7 @@
                   <a:schemeClr val="accent2"/>
                 </a:solidFill>
               </a:rPr>
-              <a:t>[s] ([ms] per epoch)</a:t>
+              <a:t>[s]</a:t>
             </a:r>
             <a:endParaRPr lang="en-US" sz="1400" dirty="0"/>
           </a:p>
@@ -11271,77 +11135,40 @@
           </a:p>
         </p:txBody>
       </p:sp>
-      <p:sp>
-        <p:nvSpPr>
-          <p:cNvPr id="3" name="figure placeholder"/>
-          <p:cNvSpPr/>
+      <p:pic>
+        <p:nvPicPr>
+          <p:cNvPr id="3" name="Image 0" descr="CUP final model learning curves: MSE and MEE">    </p:cNvPr>
+          <p:cNvPicPr>
+            <a:picLocks noChangeAspect="1"/>
+          </p:cNvPicPr>
           <p:nvPr/>
-        </p:nvSpPr>
+        </p:nvPicPr>
+        <p:blipFill>
+          <a:blip r:embed="rId1"/>
+          <a:stretch>
+            <a:fillRect/>
+          </a:stretch>
+        </p:blipFill>
         <p:spPr>
           <a:xfrm>
             <a:off x="457200" y="960120"/>
-            <a:ext cx="8229600" cy="3108960"/>
+            <a:ext cx="8229600" cy="2790207"/>
           </a:xfrm>
           <a:prstGeom prst="rect">
             <a:avLst/>
           </a:prstGeom>
-          <a:solidFill>
-            <a:schemeClr val="bg1"/>
-          </a:solidFill>
-          <a:ln w="15875">
-            <a:solidFill>
-              <a:srgbClr val="9DB0C6"/>
-            </a:solidFill>
-            <a:prstDash val="dash"/>
-          </a:ln>
-        </p:spPr>
-      </p:sp>
-      <p:sp>
-        <p:nvSpPr>
-          <p:cNvPr id="4" name="Text 2"/>
+        </p:spPr>
+      </p:pic>
+      <p:sp>
+        <p:nvSpPr>
+          <p:cNvPr id="4" name="Text 1"/>
           <p:cNvSpPr txBox="1"/>
           <p:nvPr/>
         </p:nvSpPr>
         <p:spPr>
           <a:xfrm>
-            <a:off x="640080" y="960120"/>
-            <a:ext cx="7863840" cy="3108960"/>
-          </a:xfrm>
-          <a:prstGeom prst="rect">
-            <a:avLst/>
-          </a:prstGeom>
-          <a:noFill/>
-          <a:ln/>
-        </p:spPr>
-        <p:txBody>
-          <a:bodyPr wrap="square" lIns="635" tIns="635" rIns="635" bIns="635" rtlCol="0" anchor="ctr"/>
-          <a:lstStyle/>
-          <a:p>
-            <a:pPr algn="ctr" indent="0" marL="0">
-              <a:buNone/>
-            </a:pPr>
-            <a:r>
-              <a:rPr lang="en-US" sz="1400" i="1" dirty="0">
-                <a:solidFill>
-                  <a:schemeClr val="accent2"/>
-                </a:solidFill>
-              </a:rPr>
-              <a:t>[Final model plot: MSE (left) | MEE (right), TR solid / internal TS dashed]</a:t>
-            </a:r>
-            <a:endParaRPr lang="en-US" sz="1400" dirty="0"/>
-          </a:p>
-        </p:txBody>
-      </p:sp>
-      <p:sp>
-        <p:nvSpPr>
-          <p:cNvPr id="5" name="Text 3"/>
-          <p:cNvSpPr txBox="1"/>
-          <p:nvPr/>
-        </p:nvSpPr>
-        <p:spPr>
-          <a:xfrm>
-            <a:off x="457200" y="4133088"/>
-            <a:ext cx="8229600" cy="502920"/>
+            <a:off x="457200" y="3841767"/>
+            <a:ext cx="8229600" cy="731520"/>
           </a:xfrm>
           <a:prstGeom prst="rect">
             <a:avLst/>
@@ -11362,7 +11189,7 @@
                   <a:schemeClr val="accent3"/>
                 </a:solidFill>
               </a:rPr>
-              <a:t>Fig. 4. Final retraining: MSE (left) and MEE in the original scale (right); training solid, internal test dashed.</a:t>
+              <a:t>Fig. 6. Assessment retraining on the 400 design patterns (trial with median TS MEE): MSE on standardized targets (left), MEE (right); training solid, internal test dashed.</a:t>
             </a:r>
             <a:endParaRPr lang="en-US" sz="1400" dirty="0"/>
           </a:p>
@@ -13478,7 +13305,7 @@
                   <a:schemeClr val="tx1"/>
                 </a:solidFill>
               </a:rPr>
-              <a:t>A multilayer perceptron trained by back-propagation (SGD with momentum, L2) written from scratch with NumPy. ML-CUP25: grid search with 5-fold CV on 80% of the data, </a:t>
+              <a:t>A multilayer perceptron trained by back-propagation (SGD with momentum, L2) written from scratch with NumPy. ML-CUP25: grid search with </a:t>
             </a:r>
             <a:pPr indent="0" marL="0">
               <a:buNone/>
@@ -13489,7 +13316,7 @@
                   <a:schemeClr val="accent2"/>
                 </a:solidFill>
               </a:rPr>
-              <a:t>[T]</a:t>
+              <a:t>3</a:t>
             </a:r>
             <a:pPr indent="0" marL="0">
               <a:buNone/>
@@ -13500,7 +13327,7 @@
                   <a:schemeClr val="tx1"/>
                 </a:solidFill>
               </a:rPr>
-              <a:t> random initializations per configuration, internal test on the other 20%. Final model: one network, </a:t>
+              <a:t>-fold CV on 80% of the data and </a:t>
             </a:r>
             <a:pPr indent="0" marL="0">
               <a:buNone/>
@@ -13511,7 +13338,7 @@
                   <a:schemeClr val="accent2"/>
                 </a:solidFill>
               </a:rPr>
-              <a:t>[architecture, η, α, λ]</a:t>
+              <a:t>10</a:t>
             </a:r>
             <a:pPr indent="0" marL="0">
               <a:buNone/>
@@ -13522,29 +13349,7 @@
                   <a:schemeClr val="tx1"/>
                 </a:solidFill>
               </a:rPr>
-              <a:t>, internal test MEE </a:t>
-            </a:r>
-            <a:pPr indent="0" marL="0">
-              <a:buNone/>
-            </a:pPr>
-            <a:r>
-              <a:rPr lang="en-US" sz="1400" i="1" dirty="0">
-                <a:solidFill>
-                  <a:schemeClr val="accent2"/>
-                </a:solidFill>
-              </a:rPr>
-              <a:t>[value]</a:t>
-            </a:r>
-            <a:pPr indent="0" marL="0">
-              <a:buNone/>
-            </a:pPr>
-            <a:r>
-              <a:rPr lang="en-US" sz="1400" dirty="0">
-                <a:solidFill>
-                  <a:schemeClr val="tx1"/>
-                </a:solidFill>
-              </a:rPr>
-              <a:t>.</a:t>
+              <a:t> random initializations per configuration, internal test on the other 20%. Final model: one 12-64-64-4 ReLU network (η 0.01, α 0.9, λ 0.01), internal test MEE 20.85 ± 0.29.</a:t>
             </a:r>
             <a:endParaRPr lang="en-US" sz="1400" dirty="0"/>
           </a:p>
@@ -14169,7 +13974,7 @@
                   <a:schemeClr val="tx2"/>
                 </a:solidFill>
               </a:rPr>
-              <a:t>A.2 MONK model selection</a:t>
+              <a:t>A.2 CUP screening: learning curves</a:t>
             </a:r>
             <a:endParaRPr lang="en-US" sz="2600" dirty="0"/>
           </a:p>
@@ -14177,50 +13982,14 @@
       </p:sp>
       <p:sp>
         <p:nvSpPr>
-          <p:cNvPr id="3" name="Text 1"/>
-          <p:cNvSpPr txBox="1"/>
-          <p:nvPr/>
-        </p:nvSpPr>
-        <p:spPr>
-          <a:xfrm>
-            <a:off x="457200" y="960120"/>
-            <a:ext cx="8229600" cy="320040"/>
-          </a:xfrm>
-          <a:prstGeom prst="rect">
-            <a:avLst/>
-          </a:prstGeom>
-          <a:noFill/>
-          <a:ln/>
-        </p:spPr>
-        <p:txBody>
-          <a:bodyPr wrap="square" lIns="635" tIns="635" rIns="635" bIns="635" rtlCol="0" anchor="t"/>
-          <a:lstStyle/>
-          <a:p>
-            <a:pPr indent="0" marL="0">
-              <a:buNone/>
-            </a:pPr>
-            <a:r>
-              <a:rPr lang="en-US" sz="1400" i="1" dirty="0">
-                <a:solidFill>
-                  <a:schemeClr val="accent3"/>
-                </a:solidFill>
-              </a:rPr>
-              <a:t>Table A.2. Grids and selected configuration per MONK task (stratified hold-out, 20% VL).</a:t>
-            </a:r>
-            <a:endParaRPr lang="en-US" sz="1400" dirty="0"/>
-          </a:p>
-        </p:txBody>
-      </p:sp>
-      <p:sp>
-        <p:nvSpPr>
-          <p:cNvPr id="4" name="figure placeholder"/>
+          <p:cNvPr id="3" name="figure placeholder"/>
           <p:cNvSpPr/>
           <p:nvPr/>
         </p:nvSpPr>
         <p:spPr>
           <a:xfrm>
-            <a:off x="457200" y="1325880"/>
-            <a:ext cx="8229600" cy="3246120"/>
+            <a:off x="457200" y="960120"/>
+            <a:ext cx="4023360" cy="1463040"/>
           </a:xfrm>
           <a:prstGeom prst="rect">
             <a:avLst/>
@@ -14238,14 +14007,122 @@
       </p:sp>
       <p:sp>
         <p:nvSpPr>
+          <p:cNvPr id="4" name="Text 2"/>
+          <p:cNvSpPr txBox="1"/>
+          <p:nvPr/>
+        </p:nvSpPr>
+        <p:spPr>
+          <a:xfrm>
+            <a:off x="640080" y="960120"/>
+            <a:ext cx="3657600" cy="1463040"/>
+          </a:xfrm>
+          <a:prstGeom prst="rect">
+            <a:avLst/>
+          </a:prstGeom>
+          <a:noFill/>
+          <a:ln/>
+        </p:spPr>
+        <p:txBody>
+          <a:bodyPr wrap="square" lIns="635" tIns="635" rIns="635" bIns="635" rtlCol="0" anchor="ctr"/>
+          <a:lstStyle/>
+          <a:p>
+            <a:pPr algn="ctr" indent="0" marL="0">
+              <a:buNone/>
+            </a:pPr>
+            <a:r>
+              <a:rPr lang="en-US" sz="1400" i="1" dirty="0">
+                <a:solidFill>
+                  <a:schemeClr val="accent2"/>
+                </a:solidFill>
+              </a:rPr>
+              <a:t>[Fig. A.1: screening curve]</a:t>
+            </a:r>
+            <a:endParaRPr lang="en-US" sz="1400" dirty="0"/>
+          </a:p>
+        </p:txBody>
+      </p:sp>
+      <p:sp>
+        <p:nvSpPr>
           <p:cNvPr id="5" name="Text 3"/>
           <p:cNvSpPr txBox="1"/>
           <p:nvPr/>
         </p:nvSpPr>
         <p:spPr>
           <a:xfrm>
-            <a:off x="640080" y="1325880"/>
-            <a:ext cx="7863840" cy="3246120"/>
+            <a:off x="457200" y="2441448"/>
+            <a:ext cx="4023360" cy="320040"/>
+          </a:xfrm>
+          <a:prstGeom prst="rect">
+            <a:avLst/>
+          </a:prstGeom>
+          <a:noFill/>
+          <a:ln/>
+        </p:spPr>
+        <p:txBody>
+          <a:bodyPr wrap="square" lIns="635" tIns="635" rIns="635" bIns="635" rtlCol="0" anchor="t"/>
+          <a:lstStyle/>
+          <a:p>
+            <a:pPr indent="0" marL="0">
+              <a:buNone/>
+            </a:pPr>
+            <a:r>
+              <a:rPr lang="en-US" sz="1400" i="1" dirty="0">
+                <a:solidFill>
+                  <a:schemeClr val="accent3"/>
+                </a:solidFill>
+              </a:rPr>
+              <a:t>Fig. A.1. </a:t>
+            </a:r>
+            <a:pPr indent="0" marL="0">
+              <a:buNone/>
+            </a:pPr>
+            <a:r>
+              <a:rPr lang="en-US" sz="1400" i="1" dirty="0">
+                <a:solidFill>
+                  <a:schemeClr val="accent2"/>
+                </a:solidFill>
+              </a:rPr>
+              <a:t>[caption]</a:t>
+            </a:r>
+            <a:endParaRPr lang="en-US" sz="1400" dirty="0"/>
+          </a:p>
+        </p:txBody>
+      </p:sp>
+      <p:sp>
+        <p:nvSpPr>
+          <p:cNvPr id="6" name="figure placeholder"/>
+          <p:cNvSpPr/>
+          <p:nvPr/>
+        </p:nvSpPr>
+        <p:spPr>
+          <a:xfrm>
+            <a:off x="4663440" y="960120"/>
+            <a:ext cx="4023360" cy="1463040"/>
+          </a:xfrm>
+          <a:prstGeom prst="rect">
+            <a:avLst/>
+          </a:prstGeom>
+          <a:solidFill>
+            <a:schemeClr val="bg1"/>
+          </a:solidFill>
+          <a:ln w="15875">
+            <a:solidFill>
+              <a:srgbClr val="9DB0C6"/>
+            </a:solidFill>
+            <a:prstDash val="dash"/>
+          </a:ln>
+        </p:spPr>
+      </p:sp>
+      <p:sp>
+        <p:nvSpPr>
+          <p:cNvPr id="7" name="Text 5"/>
+          <p:cNvSpPr txBox="1"/>
+          <p:nvPr/>
+        </p:nvSpPr>
+        <p:spPr>
+          <a:xfrm>
+            <a:off x="4846320" y="960120"/>
+            <a:ext cx="3657600" cy="1463040"/>
           </a:xfrm>
           <a:prstGeom prst="rect">
             <a:avLst/>
@@ -14266,7 +14143,270 @@
                   <a:schemeClr val="accent2"/>
                 </a:solidFill>
               </a:rPr>
-              <a:t>[Table A.2: grid values, validation schema and selected hyper-parameters per MONK task]</a:t>
+              <a:t>[Fig. A.2: screening curve]</a:t>
+            </a:r>
+            <a:endParaRPr lang="en-US" sz="1400" dirty="0"/>
+          </a:p>
+        </p:txBody>
+      </p:sp>
+      <p:sp>
+        <p:nvSpPr>
+          <p:cNvPr id="8" name="Text 6"/>
+          <p:cNvSpPr txBox="1"/>
+          <p:nvPr/>
+        </p:nvSpPr>
+        <p:spPr>
+          <a:xfrm>
+            <a:off x="4663440" y="2441448"/>
+            <a:ext cx="4023360" cy="320040"/>
+          </a:xfrm>
+          <a:prstGeom prst="rect">
+            <a:avLst/>
+          </a:prstGeom>
+          <a:noFill/>
+          <a:ln/>
+        </p:spPr>
+        <p:txBody>
+          <a:bodyPr wrap="square" lIns="635" tIns="635" rIns="635" bIns="635" rtlCol="0" anchor="t"/>
+          <a:lstStyle/>
+          <a:p>
+            <a:pPr indent="0" marL="0">
+              <a:buNone/>
+            </a:pPr>
+            <a:r>
+              <a:rPr lang="en-US" sz="1400" i="1" dirty="0">
+                <a:solidFill>
+                  <a:schemeClr val="accent3"/>
+                </a:solidFill>
+              </a:rPr>
+              <a:t>Fig. A.2. </a:t>
+            </a:r>
+            <a:pPr indent="0" marL="0">
+              <a:buNone/>
+            </a:pPr>
+            <a:r>
+              <a:rPr lang="en-US" sz="1400" i="1" dirty="0">
+                <a:solidFill>
+                  <a:schemeClr val="accent2"/>
+                </a:solidFill>
+              </a:rPr>
+              <a:t>[caption]</a:t>
+            </a:r>
+            <a:endParaRPr lang="en-US" sz="1400" dirty="0"/>
+          </a:p>
+        </p:txBody>
+      </p:sp>
+      <p:sp>
+        <p:nvSpPr>
+          <p:cNvPr id="9" name="figure placeholder"/>
+          <p:cNvSpPr/>
+          <p:nvPr/>
+        </p:nvSpPr>
+        <p:spPr>
+          <a:xfrm>
+            <a:off x="457200" y="2788920"/>
+            <a:ext cx="4023360" cy="1463040"/>
+          </a:xfrm>
+          <a:prstGeom prst="rect">
+            <a:avLst/>
+          </a:prstGeom>
+          <a:solidFill>
+            <a:schemeClr val="bg1"/>
+          </a:solidFill>
+          <a:ln w="15875">
+            <a:solidFill>
+              <a:srgbClr val="9DB0C6"/>
+            </a:solidFill>
+            <a:prstDash val="dash"/>
+          </a:ln>
+        </p:spPr>
+      </p:sp>
+      <p:sp>
+        <p:nvSpPr>
+          <p:cNvPr id="10" name="Text 8"/>
+          <p:cNvSpPr txBox="1"/>
+          <p:nvPr/>
+        </p:nvSpPr>
+        <p:spPr>
+          <a:xfrm>
+            <a:off x="640080" y="2788920"/>
+            <a:ext cx="3657600" cy="1463040"/>
+          </a:xfrm>
+          <a:prstGeom prst="rect">
+            <a:avLst/>
+          </a:prstGeom>
+          <a:noFill/>
+          <a:ln/>
+        </p:spPr>
+        <p:txBody>
+          <a:bodyPr wrap="square" lIns="635" tIns="635" rIns="635" bIns="635" rtlCol="0" anchor="ctr"/>
+          <a:lstStyle/>
+          <a:p>
+            <a:pPr algn="ctr" indent="0" marL="0">
+              <a:buNone/>
+            </a:pPr>
+            <a:r>
+              <a:rPr lang="en-US" sz="1400" i="1" dirty="0">
+                <a:solidFill>
+                  <a:schemeClr val="accent2"/>
+                </a:solidFill>
+              </a:rPr>
+              <a:t>[Fig. A.3: screening curve]</a:t>
+            </a:r>
+            <a:endParaRPr lang="en-US" sz="1400" dirty="0"/>
+          </a:p>
+        </p:txBody>
+      </p:sp>
+      <p:sp>
+        <p:nvSpPr>
+          <p:cNvPr id="11" name="Text 9"/>
+          <p:cNvSpPr txBox="1"/>
+          <p:nvPr/>
+        </p:nvSpPr>
+        <p:spPr>
+          <a:xfrm>
+            <a:off x="457200" y="4270248"/>
+            <a:ext cx="4023360" cy="320040"/>
+          </a:xfrm>
+          <a:prstGeom prst="rect">
+            <a:avLst/>
+          </a:prstGeom>
+          <a:noFill/>
+          <a:ln/>
+        </p:spPr>
+        <p:txBody>
+          <a:bodyPr wrap="square" lIns="635" tIns="635" rIns="635" bIns="635" rtlCol="0" anchor="t"/>
+          <a:lstStyle/>
+          <a:p>
+            <a:pPr indent="0" marL="0">
+              <a:buNone/>
+            </a:pPr>
+            <a:r>
+              <a:rPr lang="en-US" sz="1400" i="1" dirty="0">
+                <a:solidFill>
+                  <a:schemeClr val="accent3"/>
+                </a:solidFill>
+              </a:rPr>
+              <a:t>Fig. A.3. </a:t>
+            </a:r>
+            <a:pPr indent="0" marL="0">
+              <a:buNone/>
+            </a:pPr>
+            <a:r>
+              <a:rPr lang="en-US" sz="1400" i="1" dirty="0">
+                <a:solidFill>
+                  <a:schemeClr val="accent2"/>
+                </a:solidFill>
+              </a:rPr>
+              <a:t>[caption]</a:t>
+            </a:r>
+            <a:endParaRPr lang="en-US" sz="1400" dirty="0"/>
+          </a:p>
+        </p:txBody>
+      </p:sp>
+      <p:sp>
+        <p:nvSpPr>
+          <p:cNvPr id="12" name="figure placeholder"/>
+          <p:cNvSpPr/>
+          <p:nvPr/>
+        </p:nvSpPr>
+        <p:spPr>
+          <a:xfrm>
+            <a:off x="4663440" y="2788920"/>
+            <a:ext cx="4023360" cy="1463040"/>
+          </a:xfrm>
+          <a:prstGeom prst="rect">
+            <a:avLst/>
+          </a:prstGeom>
+          <a:solidFill>
+            <a:schemeClr val="bg1"/>
+          </a:solidFill>
+          <a:ln w="15875">
+            <a:solidFill>
+              <a:srgbClr val="9DB0C6"/>
+            </a:solidFill>
+            <a:prstDash val="dash"/>
+          </a:ln>
+        </p:spPr>
+      </p:sp>
+      <p:sp>
+        <p:nvSpPr>
+          <p:cNvPr id="13" name="Text 11"/>
+          <p:cNvSpPr txBox="1"/>
+          <p:nvPr/>
+        </p:nvSpPr>
+        <p:spPr>
+          <a:xfrm>
+            <a:off x="4846320" y="2788920"/>
+            <a:ext cx="3657600" cy="1463040"/>
+          </a:xfrm>
+          <a:prstGeom prst="rect">
+            <a:avLst/>
+          </a:prstGeom>
+          <a:noFill/>
+          <a:ln/>
+        </p:spPr>
+        <p:txBody>
+          <a:bodyPr wrap="square" lIns="635" tIns="635" rIns="635" bIns="635" rtlCol="0" anchor="ctr"/>
+          <a:lstStyle/>
+          <a:p>
+            <a:pPr algn="ctr" indent="0" marL="0">
+              <a:buNone/>
+            </a:pPr>
+            <a:r>
+              <a:rPr lang="en-US" sz="1400" i="1" dirty="0">
+                <a:solidFill>
+                  <a:schemeClr val="accent2"/>
+                </a:solidFill>
+              </a:rPr>
+              <a:t>[Fig. A.4: screening curve]</a:t>
+            </a:r>
+            <a:endParaRPr lang="en-US" sz="1400" dirty="0"/>
+          </a:p>
+        </p:txBody>
+      </p:sp>
+      <p:sp>
+        <p:nvSpPr>
+          <p:cNvPr id="14" name="Text 12"/>
+          <p:cNvSpPr txBox="1"/>
+          <p:nvPr/>
+        </p:nvSpPr>
+        <p:spPr>
+          <a:xfrm>
+            <a:off x="4663440" y="4270248"/>
+            <a:ext cx="4023360" cy="320040"/>
+          </a:xfrm>
+          <a:prstGeom prst="rect">
+            <a:avLst/>
+          </a:prstGeom>
+          <a:noFill/>
+          <a:ln/>
+        </p:spPr>
+        <p:txBody>
+          <a:bodyPr wrap="square" lIns="635" tIns="635" rIns="635" bIns="635" rtlCol="0" anchor="t"/>
+          <a:lstStyle/>
+          <a:p>
+            <a:pPr indent="0" marL="0">
+              <a:buNone/>
+            </a:pPr>
+            <a:r>
+              <a:rPr lang="en-US" sz="1400" i="1" dirty="0">
+                <a:solidFill>
+                  <a:schemeClr val="accent3"/>
+                </a:solidFill>
+              </a:rPr>
+              <a:t>Fig. A.4. </a:t>
+            </a:r>
+            <a:pPr indent="0" marL="0">
+              <a:buNone/>
+            </a:pPr>
+            <a:r>
+              <a:rPr lang="en-US" sz="1400" i="1" dirty="0">
+                <a:solidFill>
+                  <a:schemeClr val="accent2"/>
+                </a:solidFill>
+              </a:rPr>
+              <a:t>[caption]</a:t>
             </a:r>
             <a:endParaRPr lang="en-US" sz="1400" dirty="0"/>
           </a:p>
@@ -14374,7 +14514,7 @@
                   <a:schemeClr val="tx2"/>
                 </a:solidFill>
               </a:rPr>
-              <a:t>A.3 CUP screening: learning curves</a:t>
+              <a:t>A.3 Variability: folds vs initializations</a:t>
             </a:r>
             <a:endParaRPr lang="en-US" sz="2600" dirty="0"/>
           </a:p>
@@ -14389,7 +14529,7 @@
         <p:spPr>
           <a:xfrm>
             <a:off x="457200" y="960120"/>
-            <a:ext cx="4023360" cy="1463040"/>
+            <a:ext cx="8229600" cy="3108960"/>
           </a:xfrm>
           <a:prstGeom prst="rect">
             <a:avLst/>
@@ -14414,7 +14554,7 @@
         <p:spPr>
           <a:xfrm>
             <a:off x="640080" y="960120"/>
-            <a:ext cx="3657600" cy="1463040"/>
+            <a:ext cx="7863840" cy="3108960"/>
           </a:xfrm>
           <a:prstGeom prst="rect">
             <a:avLst/>
@@ -14435,7 +14575,7 @@
                   <a:schemeClr val="accent2"/>
                 </a:solidFill>
               </a:rPr>
-              <a:t>[Fig. A.1: screening curve]</a:t>
+              <a:t>[Std of VL MEE across folds and across initializations for the top configurations]</a:t>
             </a:r>
             <a:endParaRPr lang="en-US" sz="1400" dirty="0"/>
           </a:p>
@@ -14449,8 +14589,8 @@
         </p:nvSpPr>
         <p:spPr>
           <a:xfrm>
-            <a:off x="457200" y="2441448"/>
-            <a:ext cx="4023360" cy="320040"/>
+            <a:off x="457200" y="4133088"/>
+            <a:ext cx="8229600" cy="457200"/>
           </a:xfrm>
           <a:prstGeom prst="rect">
             <a:avLst/>
@@ -14471,331 +14611,7 @@
                   <a:schemeClr val="accent3"/>
                 </a:solidFill>
               </a:rPr>
-              <a:t>Fig. A.1. </a:t>
-            </a:r>
-            <a:pPr indent="0" marL="0">
-              <a:buNone/>
-            </a:pPr>
-            <a:r>
-              <a:rPr lang="en-US" sz="1400" i="1" dirty="0">
-                <a:solidFill>
-                  <a:schemeClr val="accent2"/>
-                </a:solidFill>
-              </a:rPr>
-              <a:t>[caption]</a:t>
-            </a:r>
-            <a:endParaRPr lang="en-US" sz="1400" dirty="0"/>
-          </a:p>
-        </p:txBody>
-      </p:sp>
-      <p:sp>
-        <p:nvSpPr>
-          <p:cNvPr id="6" name="figure placeholder"/>
-          <p:cNvSpPr/>
-          <p:nvPr/>
-        </p:nvSpPr>
-        <p:spPr>
-          <a:xfrm>
-            <a:off x="4663440" y="960120"/>
-            <a:ext cx="4023360" cy="1463040"/>
-          </a:xfrm>
-          <a:prstGeom prst="rect">
-            <a:avLst/>
-          </a:prstGeom>
-          <a:solidFill>
-            <a:schemeClr val="bg1"/>
-          </a:solidFill>
-          <a:ln w="15875">
-            <a:solidFill>
-              <a:srgbClr val="9DB0C6"/>
-            </a:solidFill>
-            <a:prstDash val="dash"/>
-          </a:ln>
-        </p:spPr>
-      </p:sp>
-      <p:sp>
-        <p:nvSpPr>
-          <p:cNvPr id="7" name="Text 5"/>
-          <p:cNvSpPr txBox="1"/>
-          <p:nvPr/>
-        </p:nvSpPr>
-        <p:spPr>
-          <a:xfrm>
-            <a:off x="4846320" y="960120"/>
-            <a:ext cx="3657600" cy="1463040"/>
-          </a:xfrm>
-          <a:prstGeom prst="rect">
-            <a:avLst/>
-          </a:prstGeom>
-          <a:noFill/>
-          <a:ln/>
-        </p:spPr>
-        <p:txBody>
-          <a:bodyPr wrap="square" lIns="635" tIns="635" rIns="635" bIns="635" rtlCol="0" anchor="ctr"/>
-          <a:lstStyle/>
-          <a:p>
-            <a:pPr algn="ctr" indent="0" marL="0">
-              <a:buNone/>
-            </a:pPr>
-            <a:r>
-              <a:rPr lang="en-US" sz="1400" i="1" dirty="0">
-                <a:solidFill>
-                  <a:schemeClr val="accent2"/>
-                </a:solidFill>
-              </a:rPr>
-              <a:t>[Fig. A.2: screening curve]</a:t>
-            </a:r>
-            <a:endParaRPr lang="en-US" sz="1400" dirty="0"/>
-          </a:p>
-        </p:txBody>
-      </p:sp>
-      <p:sp>
-        <p:nvSpPr>
-          <p:cNvPr id="8" name="Text 6"/>
-          <p:cNvSpPr txBox="1"/>
-          <p:nvPr/>
-        </p:nvSpPr>
-        <p:spPr>
-          <a:xfrm>
-            <a:off x="4663440" y="2441448"/>
-            <a:ext cx="4023360" cy="320040"/>
-          </a:xfrm>
-          <a:prstGeom prst="rect">
-            <a:avLst/>
-          </a:prstGeom>
-          <a:noFill/>
-          <a:ln/>
-        </p:spPr>
-        <p:txBody>
-          <a:bodyPr wrap="square" lIns="635" tIns="635" rIns="635" bIns="635" rtlCol="0" anchor="t"/>
-          <a:lstStyle/>
-          <a:p>
-            <a:pPr indent="0" marL="0">
-              <a:buNone/>
-            </a:pPr>
-            <a:r>
-              <a:rPr lang="en-US" sz="1400" i="1" dirty="0">
-                <a:solidFill>
-                  <a:schemeClr val="accent3"/>
-                </a:solidFill>
-              </a:rPr>
-              <a:t>Fig. A.2. </a:t>
-            </a:r>
-            <a:pPr indent="0" marL="0">
-              <a:buNone/>
-            </a:pPr>
-            <a:r>
-              <a:rPr lang="en-US" sz="1400" i="1" dirty="0">
-                <a:solidFill>
-                  <a:schemeClr val="accent2"/>
-                </a:solidFill>
-              </a:rPr>
-              <a:t>[caption]</a:t>
-            </a:r>
-            <a:endParaRPr lang="en-US" sz="1400" dirty="0"/>
-          </a:p>
-        </p:txBody>
-      </p:sp>
-      <p:sp>
-        <p:nvSpPr>
-          <p:cNvPr id="9" name="figure placeholder"/>
-          <p:cNvSpPr/>
-          <p:nvPr/>
-        </p:nvSpPr>
-        <p:spPr>
-          <a:xfrm>
-            <a:off x="457200" y="2788920"/>
-            <a:ext cx="4023360" cy="1463040"/>
-          </a:xfrm>
-          <a:prstGeom prst="rect">
-            <a:avLst/>
-          </a:prstGeom>
-          <a:solidFill>
-            <a:schemeClr val="bg1"/>
-          </a:solidFill>
-          <a:ln w="15875">
-            <a:solidFill>
-              <a:srgbClr val="9DB0C6"/>
-            </a:solidFill>
-            <a:prstDash val="dash"/>
-          </a:ln>
-        </p:spPr>
-      </p:sp>
-      <p:sp>
-        <p:nvSpPr>
-          <p:cNvPr id="10" name="Text 8"/>
-          <p:cNvSpPr txBox="1"/>
-          <p:nvPr/>
-        </p:nvSpPr>
-        <p:spPr>
-          <a:xfrm>
-            <a:off x="640080" y="2788920"/>
-            <a:ext cx="3657600" cy="1463040"/>
-          </a:xfrm>
-          <a:prstGeom prst="rect">
-            <a:avLst/>
-          </a:prstGeom>
-          <a:noFill/>
-          <a:ln/>
-        </p:spPr>
-        <p:txBody>
-          <a:bodyPr wrap="square" lIns="635" tIns="635" rIns="635" bIns="635" rtlCol="0" anchor="ctr"/>
-          <a:lstStyle/>
-          <a:p>
-            <a:pPr algn="ctr" indent="0" marL="0">
-              <a:buNone/>
-            </a:pPr>
-            <a:r>
-              <a:rPr lang="en-US" sz="1400" i="1" dirty="0">
-                <a:solidFill>
-                  <a:schemeClr val="accent2"/>
-                </a:solidFill>
-              </a:rPr>
-              <a:t>[Fig. A.3: screening curve]</a:t>
-            </a:r>
-            <a:endParaRPr lang="en-US" sz="1400" dirty="0"/>
-          </a:p>
-        </p:txBody>
-      </p:sp>
-      <p:sp>
-        <p:nvSpPr>
-          <p:cNvPr id="11" name="Text 9"/>
-          <p:cNvSpPr txBox="1"/>
-          <p:nvPr/>
-        </p:nvSpPr>
-        <p:spPr>
-          <a:xfrm>
-            <a:off x="457200" y="4270248"/>
-            <a:ext cx="4023360" cy="320040"/>
-          </a:xfrm>
-          <a:prstGeom prst="rect">
-            <a:avLst/>
-          </a:prstGeom>
-          <a:noFill/>
-          <a:ln/>
-        </p:spPr>
-        <p:txBody>
-          <a:bodyPr wrap="square" lIns="635" tIns="635" rIns="635" bIns="635" rtlCol="0" anchor="t"/>
-          <a:lstStyle/>
-          <a:p>
-            <a:pPr indent="0" marL="0">
-              <a:buNone/>
-            </a:pPr>
-            <a:r>
-              <a:rPr lang="en-US" sz="1400" i="1" dirty="0">
-                <a:solidFill>
-                  <a:schemeClr val="accent3"/>
-                </a:solidFill>
-              </a:rPr>
-              <a:t>Fig. A.3. </a:t>
-            </a:r>
-            <a:pPr indent="0" marL="0">
-              <a:buNone/>
-            </a:pPr>
-            <a:r>
-              <a:rPr lang="en-US" sz="1400" i="1" dirty="0">
-                <a:solidFill>
-                  <a:schemeClr val="accent2"/>
-                </a:solidFill>
-              </a:rPr>
-              <a:t>[caption]</a:t>
-            </a:r>
-            <a:endParaRPr lang="en-US" sz="1400" dirty="0"/>
-          </a:p>
-        </p:txBody>
-      </p:sp>
-      <p:sp>
-        <p:nvSpPr>
-          <p:cNvPr id="12" name="figure placeholder"/>
-          <p:cNvSpPr/>
-          <p:nvPr/>
-        </p:nvSpPr>
-        <p:spPr>
-          <a:xfrm>
-            <a:off x="4663440" y="2788920"/>
-            <a:ext cx="4023360" cy="1463040"/>
-          </a:xfrm>
-          <a:prstGeom prst="rect">
-            <a:avLst/>
-          </a:prstGeom>
-          <a:solidFill>
-            <a:schemeClr val="bg1"/>
-          </a:solidFill>
-          <a:ln w="15875">
-            <a:solidFill>
-              <a:srgbClr val="9DB0C6"/>
-            </a:solidFill>
-            <a:prstDash val="dash"/>
-          </a:ln>
-        </p:spPr>
-      </p:sp>
-      <p:sp>
-        <p:nvSpPr>
-          <p:cNvPr id="13" name="Text 11"/>
-          <p:cNvSpPr txBox="1"/>
-          <p:nvPr/>
-        </p:nvSpPr>
-        <p:spPr>
-          <a:xfrm>
-            <a:off x="4846320" y="2788920"/>
-            <a:ext cx="3657600" cy="1463040"/>
-          </a:xfrm>
-          <a:prstGeom prst="rect">
-            <a:avLst/>
-          </a:prstGeom>
-          <a:noFill/>
-          <a:ln/>
-        </p:spPr>
-        <p:txBody>
-          <a:bodyPr wrap="square" lIns="635" tIns="635" rIns="635" bIns="635" rtlCol="0" anchor="ctr"/>
-          <a:lstStyle/>
-          <a:p>
-            <a:pPr algn="ctr" indent="0" marL="0">
-              <a:buNone/>
-            </a:pPr>
-            <a:r>
-              <a:rPr lang="en-US" sz="1400" i="1" dirty="0">
-                <a:solidFill>
-                  <a:schemeClr val="accent2"/>
-                </a:solidFill>
-              </a:rPr>
-              <a:t>[Fig. A.4: screening curve]</a:t>
-            </a:r>
-            <a:endParaRPr lang="en-US" sz="1400" dirty="0"/>
-          </a:p>
-        </p:txBody>
-      </p:sp>
-      <p:sp>
-        <p:nvSpPr>
-          <p:cNvPr id="14" name="Text 12"/>
-          <p:cNvSpPr txBox="1"/>
-          <p:nvPr/>
-        </p:nvSpPr>
-        <p:spPr>
-          <a:xfrm>
-            <a:off x="4663440" y="4270248"/>
-            <a:ext cx="4023360" cy="320040"/>
-          </a:xfrm>
-          <a:prstGeom prst="rect">
-            <a:avLst/>
-          </a:prstGeom>
-          <a:noFill/>
-          <a:ln/>
-        </p:spPr>
-        <p:txBody>
-          <a:bodyPr wrap="square" lIns="635" tIns="635" rIns="635" bIns="635" rtlCol="0" anchor="t"/>
-          <a:lstStyle/>
-          <a:p>
-            <a:pPr indent="0" marL="0">
-              <a:buNone/>
-            </a:pPr>
-            <a:r>
-              <a:rPr lang="en-US" sz="1400" i="1" dirty="0">
-                <a:solidFill>
-                  <a:schemeClr val="accent3"/>
-                </a:solidFill>
-              </a:rPr>
-              <a:t>Fig. A.4. </a:t>
+              <a:t>Fig. A.5. </a:t>
             </a:r>
             <a:pPr indent="0" marL="0">
               <a:buNone/>
@@ -14914,7 +14730,7 @@
                   <a:schemeClr val="tx2"/>
                 </a:solidFill>
               </a:rPr>
-              <a:t>A.4 Variability: folds vs initializations</a:t>
+              <a:t>A.4 Reproducibility</a:t>
             </a:r>
             <a:endParaRPr lang="en-US" sz="2600" dirty="0"/>
           </a:p>
@@ -14922,75 +14738,14 @@
       </p:sp>
       <p:sp>
         <p:nvSpPr>
-          <p:cNvPr id="3" name="figure placeholder"/>
-          <p:cNvSpPr/>
-          <p:nvPr/>
-        </p:nvSpPr>
-        <p:spPr>
-          <a:xfrm>
-            <a:off x="457200" y="960120"/>
-            <a:ext cx="8229600" cy="3108960"/>
-          </a:xfrm>
-          <a:prstGeom prst="rect">
-            <a:avLst/>
-          </a:prstGeom>
-          <a:solidFill>
-            <a:schemeClr val="bg1"/>
-          </a:solidFill>
-          <a:ln w="15875">
-            <a:solidFill>
-              <a:srgbClr val="9DB0C6"/>
-            </a:solidFill>
-            <a:prstDash val="dash"/>
-          </a:ln>
-        </p:spPr>
-      </p:sp>
-      <p:sp>
-        <p:nvSpPr>
-          <p:cNvPr id="4" name="Text 2"/>
+          <p:cNvPr id="3" name="Text 1"/>
           <p:cNvSpPr txBox="1"/>
           <p:nvPr/>
         </p:nvSpPr>
         <p:spPr>
           <a:xfrm>
-            <a:off x="640080" y="960120"/>
-            <a:ext cx="7863840" cy="3108960"/>
-          </a:xfrm>
-          <a:prstGeom prst="rect">
-            <a:avLst/>
-          </a:prstGeom>
-          <a:noFill/>
-          <a:ln/>
-        </p:spPr>
-        <p:txBody>
-          <a:bodyPr wrap="square" lIns="635" tIns="635" rIns="635" bIns="635" rtlCol="0" anchor="ctr"/>
-          <a:lstStyle/>
-          <a:p>
-            <a:pPr algn="ctr" indent="0" marL="0">
-              <a:buNone/>
-            </a:pPr>
-            <a:r>
-              <a:rPr lang="en-US" sz="1400" i="1" dirty="0">
-                <a:solidFill>
-                  <a:schemeClr val="accent2"/>
-                </a:solidFill>
-              </a:rPr>
-              <a:t>[Std of VL MEE across folds and across initializations for the top configurations]</a:t>
-            </a:r>
-            <a:endParaRPr lang="en-US" sz="1400" dirty="0"/>
-          </a:p>
-        </p:txBody>
-      </p:sp>
-      <p:sp>
-        <p:nvSpPr>
-          <p:cNvPr id="5" name="Text 3"/>
-          <p:cNvSpPr txBox="1"/>
-          <p:nvPr/>
-        </p:nvSpPr>
-        <p:spPr>
-          <a:xfrm>
-            <a:off x="457200" y="4133088"/>
-            <a:ext cx="8229600" cy="457200"/>
+            <a:off x="457200" y="1005840"/>
+            <a:ext cx="8229600" cy="3566160"/>
           </a:xfrm>
           <a:prstGeom prst="rect">
             <a:avLst/>
@@ -15003,15 +14758,72 @@
           <a:lstStyle/>
           <a:p>
             <a:pPr indent="0" marL="0">
+              <a:spcAft>
+                <a:spcPts val="800"/>
+              </a:spcAft>
+              <a:buNone/>
+            </a:pPr>
+            <a:r>
+              <a:rPr lang="en-US" sz="1400" dirty="0">
+                <a:solidFill>
+                  <a:schemeClr val="tx1"/>
+                </a:solidFill>
+              </a:rPr>
+              <a:t>Every run is a JSON config; results, seeds and plots are saved in results/&lt;task&gt;/&lt;run_id&gt;/.</a:t>
+            </a:r>
+            <a:endParaRPr lang="en-US" sz="1400" dirty="0"/>
+          </a:p>
+          <a:p>
+            <a:pPr indent="0" marL="0">
+              <a:spcAft>
+                <a:spcPts val="400"/>
+              </a:spcAft>
+              <a:buNone/>
+            </a:pPr>
+            <a:r>
+              <a:rPr lang="en-US" sz="1400" dirty="0">
+                <a:solidFill>
+                  <a:schemeClr val="tx1"/>
+                </a:solidFill>
+                <a:latin typeface="Courier New" pitchFamily="34" charset="0"/>
+                <a:ea typeface="Courier New" pitchFamily="34" charset="-122"/>
+                <a:cs typeface="Courier New" pitchFamily="34" charset="-120"/>
+              </a:rPr>
+              <a:t>python -m runner --config configs/cup/</a:t>
+            </a:r>
+            <a:pPr indent="0" marL="0">
               <a:buNone/>
             </a:pPr>
             <a:r>
               <a:rPr lang="en-US" sz="1400" i="1" dirty="0">
                 <a:solidFill>
-                  <a:schemeClr val="accent3"/>
-                </a:solidFill>
-              </a:rPr>
-              <a:t>Fig. A.5. </a:t>
+                  <a:schemeClr val="accent2"/>
+                </a:solidFill>
+                <a:latin typeface="Courier New" pitchFamily="34" charset="0"/>
+                <a:ea typeface="Courier New" pitchFamily="34" charset="-122"/>
+                <a:cs typeface="Courier New" pitchFamily="34" charset="-120"/>
+              </a:rPr>
+              <a:t>[final select].json</a:t>
+            </a:r>
+            <a:endParaRPr lang="en-US" sz="1400" dirty="0"/>
+          </a:p>
+          <a:p>
+            <a:pPr indent="0" marL="0">
+              <a:spcAft>
+                <a:spcPts val="400"/>
+              </a:spcAft>
+              <a:buNone/>
+            </a:pPr>
+            <a:r>
+              <a:rPr lang="en-US" sz="1400" dirty="0">
+                <a:solidFill>
+                  <a:schemeClr val="tx1"/>
+                </a:solidFill>
+                <a:latin typeface="Courier New" pitchFamily="34" charset="0"/>
+                <a:ea typeface="Courier New" pitchFamily="34" charset="-122"/>
+                <a:cs typeface="Courier New" pitchFamily="34" charset="-120"/>
+              </a:rPr>
+              <a:t>python -m runner --config configs/cup/</a:t>
             </a:r>
             <a:pPr indent="0" marL="0">
               <a:buNone/>
@@ -15021,8 +14833,67 @@
                 <a:solidFill>
                   <a:schemeClr val="accent2"/>
                 </a:solidFill>
-              </a:rPr>
-              <a:t>[caption]</a:t>
+                <a:latin typeface="Courier New" pitchFamily="34" charset="0"/>
+                <a:ea typeface="Courier New" pitchFamily="34" charset="-122"/>
+                <a:cs typeface="Courier New" pitchFamily="34" charset="-120"/>
+              </a:rPr>
+              <a:t>[final assess].json</a:t>
+            </a:r>
+            <a:endParaRPr lang="en-US" sz="1400" dirty="0"/>
+          </a:p>
+          <a:p>
+            <a:pPr indent="0" marL="0">
+              <a:spcAft>
+                <a:spcPts val="800"/>
+              </a:spcAft>
+              <a:buNone/>
+            </a:pPr>
+            <a:r>
+              <a:rPr lang="en-US" sz="1400" dirty="0">
+                <a:solidFill>
+                  <a:schemeClr val="tx1"/>
+                </a:solidFill>
+                <a:latin typeface="Courier New" pitchFamily="34" charset="0"/>
+                <a:ea typeface="Courier New" pitchFamily="34" charset="-122"/>
+                <a:cs typeface="Courier New" pitchFamily="34" charset="-120"/>
+              </a:rPr>
+              <a:t>python experiments/cup_final.py</a:t>
+            </a:r>
+            <a:endParaRPr lang="en-US" sz="1400" dirty="0"/>
+          </a:p>
+          <a:p>
+            <a:pPr indent="0" marL="0">
+              <a:buNone/>
+            </a:pPr>
+            <a:r>
+              <a:rPr lang="en-US" sz="1400" dirty="0">
+                <a:solidFill>
+                  <a:schemeClr val="tx1"/>
+                </a:solidFill>
+              </a:rPr>
+              <a:t>Master seed </a:t>
+            </a:r>
+            <a:pPr indent="0" marL="0">
+              <a:buNone/>
+            </a:pPr>
+            <a:r>
+              <a:rPr lang="en-US" sz="1400" i="1" dirty="0">
+                <a:solidFill>
+                  <a:schemeClr val="accent2"/>
+                </a:solidFill>
+              </a:rPr>
+              <a:t>[…]</a:t>
+            </a:r>
+            <a:pPr indent="0" marL="0">
+              <a:buNone/>
+            </a:pPr>
+            <a:r>
+              <a:rPr lang="en-US" sz="1400" dirty="0">
+                <a:solidFill>
+                  <a:schemeClr val="tx1"/>
+                </a:solidFill>
+              </a:rPr>
+              <a:t>; internal test split always with seed 0.</a:t>
             </a:r>
             <a:endParaRPr lang="en-US" sz="1400" dirty="0"/>
           </a:p>
@@ -15068,277 +14939,6 @@
             <a:fld id="{F7021451-1387-4CA6-816F-3879F97B5CBC}" type="slidenum">
               <a:rPr b="0" lang="en-US"/>
               <a:t>23</a:t>
-            </a:fld>
-            <a:endParaRPr lang="en-US"/>
-          </a:p>
-        </p:txBody>
-      </p:sp>
-    </p:spTree>
-  </p:cSld>
-  <p:clrMapOvr>
-    <a:masterClrMapping/>
-  </p:clrMapOvr>
-</p:sld>
-</file>
-
-<file path=ppt/slides/slide24.xml><?xml version="1.0" encoding="utf-8"?>
-<p:sld xmlns:a="http://schemas.openxmlformats.org/drawingml/2006/main" xmlns:r="http://schemas.openxmlformats.org/officeDocument/2006/relationships" xmlns:p="http://schemas.openxmlformats.org/presentationml/2006/main">
-  <p:cSld name="Slide 24">
-    <p:spTree>
-      <p:nvGrpSpPr>
-        <p:cNvPr id="1" name=""/>
-        <p:cNvGrpSpPr/>
-        <p:nvPr/>
-      </p:nvGrpSpPr>
-      <p:grpSpPr>
-        <a:xfrm>
-          <a:off x="0" y="0"/>
-          <a:ext cx="0" cy="0"/>
-          <a:chOff x="0" y="0"/>
-          <a:chExt cx="0" cy="0"/>
-        </a:xfrm>
-      </p:grpSpPr>
-      <p:sp>
-        <p:nvSpPr>
-          <p:cNvPr id="2" name="Text 0"/>
-          <p:cNvSpPr/>
-          <p:nvPr>
-            <p:ph idx="100" type="title" hasCustomPrompt="1"/>
-          </p:nvPr>
-        </p:nvSpPr>
-        <p:spPr>
-          <a:xfrm>
-            <a:off x="457200" y="228600"/>
-            <a:ext cx="8229600" cy="594360"/>
-          </a:xfrm>
-          <a:prstGeom prst="rect">
-            <a:avLst/>
-          </a:prstGeom>
-          <a:noFill/>
-          <a:ln/>
-        </p:spPr>
-        <p:txBody>
-          <a:bodyPr wrap="square" lIns="0" tIns="0" rIns="0" bIns="0" rtlCol="0" anchor="ctr"/>
-          <a:lstStyle/>
-          <a:p>
-            <a:pPr indent="0" marL="0">
-              <a:buNone/>
-            </a:pPr>
-            <a:r>
-              <a:rPr lang="en-US" sz="2600" b="1" dirty="0">
-                <a:solidFill>
-                  <a:schemeClr val="tx2"/>
-                </a:solidFill>
-              </a:rPr>
-              <a:t>A.5 Reproducibility</a:t>
-            </a:r>
-            <a:endParaRPr lang="en-US" sz="2600" dirty="0"/>
-          </a:p>
-        </p:txBody>
-      </p:sp>
-      <p:sp>
-        <p:nvSpPr>
-          <p:cNvPr id="3" name="Text 1"/>
-          <p:cNvSpPr txBox="1"/>
-          <p:nvPr/>
-        </p:nvSpPr>
-        <p:spPr>
-          <a:xfrm>
-            <a:off x="457200" y="1005840"/>
-            <a:ext cx="8229600" cy="3566160"/>
-          </a:xfrm>
-          <a:prstGeom prst="rect">
-            <a:avLst/>
-          </a:prstGeom>
-          <a:noFill/>
-          <a:ln/>
-        </p:spPr>
-        <p:txBody>
-          <a:bodyPr wrap="square" lIns="635" tIns="635" rIns="635" bIns="635" rtlCol="0" anchor="t"/>
-          <a:lstStyle/>
-          <a:p>
-            <a:pPr indent="0" marL="0">
-              <a:spcAft>
-                <a:spcPts val="800"/>
-              </a:spcAft>
-              <a:buNone/>
-            </a:pPr>
-            <a:r>
-              <a:rPr lang="en-US" sz="1400" dirty="0">
-                <a:solidFill>
-                  <a:schemeClr val="tx1"/>
-                </a:solidFill>
-              </a:rPr>
-              <a:t>Every run is a JSON config; results, seeds and plots are saved in results/&lt;task&gt;/&lt;run_id&gt;/.</a:t>
-            </a:r>
-            <a:endParaRPr lang="en-US" sz="1400" dirty="0"/>
-          </a:p>
-          <a:p>
-            <a:pPr indent="0" marL="0">
-              <a:spcAft>
-                <a:spcPts val="400"/>
-              </a:spcAft>
-              <a:buNone/>
-            </a:pPr>
-            <a:r>
-              <a:rPr lang="en-US" sz="1400" dirty="0">
-                <a:solidFill>
-                  <a:schemeClr val="tx1"/>
-                </a:solidFill>
-                <a:latin typeface="Courier New" pitchFamily="34" charset="0"/>
-                <a:ea typeface="Courier New" pitchFamily="34" charset="-122"/>
-                <a:cs typeface="Courier New" pitchFamily="34" charset="-120"/>
-              </a:rPr>
-              <a:t>python -m runner --config configs/cup/</a:t>
-            </a:r>
-            <a:pPr indent="0" marL="0">
-              <a:buNone/>
-            </a:pPr>
-            <a:r>
-              <a:rPr lang="en-US" sz="1400" i="1" dirty="0">
-                <a:solidFill>
-                  <a:schemeClr val="accent2"/>
-                </a:solidFill>
-                <a:latin typeface="Courier New" pitchFamily="34" charset="0"/>
-                <a:ea typeface="Courier New" pitchFamily="34" charset="-122"/>
-                <a:cs typeface="Courier New" pitchFamily="34" charset="-120"/>
-              </a:rPr>
-              <a:t>[final select].json</a:t>
-            </a:r>
-            <a:endParaRPr lang="en-US" sz="1400" dirty="0"/>
-          </a:p>
-          <a:p>
-            <a:pPr indent="0" marL="0">
-              <a:spcAft>
-                <a:spcPts val="400"/>
-              </a:spcAft>
-              <a:buNone/>
-            </a:pPr>
-            <a:r>
-              <a:rPr lang="en-US" sz="1400" dirty="0">
-                <a:solidFill>
-                  <a:schemeClr val="tx1"/>
-                </a:solidFill>
-                <a:latin typeface="Courier New" pitchFamily="34" charset="0"/>
-                <a:ea typeface="Courier New" pitchFamily="34" charset="-122"/>
-                <a:cs typeface="Courier New" pitchFamily="34" charset="-120"/>
-              </a:rPr>
-              <a:t>python -m runner --config configs/cup/</a:t>
-            </a:r>
-            <a:pPr indent="0" marL="0">
-              <a:buNone/>
-            </a:pPr>
-            <a:r>
-              <a:rPr lang="en-US" sz="1400" i="1" dirty="0">
-                <a:solidFill>
-                  <a:schemeClr val="accent2"/>
-                </a:solidFill>
-                <a:latin typeface="Courier New" pitchFamily="34" charset="0"/>
-                <a:ea typeface="Courier New" pitchFamily="34" charset="-122"/>
-                <a:cs typeface="Courier New" pitchFamily="34" charset="-120"/>
-              </a:rPr>
-              <a:t>[final assess].json</a:t>
-            </a:r>
-            <a:endParaRPr lang="en-US" sz="1400" dirty="0"/>
-          </a:p>
-          <a:p>
-            <a:pPr indent="0" marL="0">
-              <a:spcAft>
-                <a:spcPts val="800"/>
-              </a:spcAft>
-              <a:buNone/>
-            </a:pPr>
-            <a:r>
-              <a:rPr lang="en-US" sz="1400" dirty="0">
-                <a:solidFill>
-                  <a:schemeClr val="tx1"/>
-                </a:solidFill>
-                <a:latin typeface="Courier New" pitchFamily="34" charset="0"/>
-                <a:ea typeface="Courier New" pitchFamily="34" charset="-122"/>
-                <a:cs typeface="Courier New" pitchFamily="34" charset="-120"/>
-              </a:rPr>
-              <a:t>python experiments/cup_final.py</a:t>
-            </a:r>
-            <a:endParaRPr lang="en-US" sz="1400" dirty="0"/>
-          </a:p>
-          <a:p>
-            <a:pPr indent="0" marL="0">
-              <a:buNone/>
-            </a:pPr>
-            <a:r>
-              <a:rPr lang="en-US" sz="1400" dirty="0">
-                <a:solidFill>
-                  <a:schemeClr val="tx1"/>
-                </a:solidFill>
-              </a:rPr>
-              <a:t>Master seed </a:t>
-            </a:r>
-            <a:pPr indent="0" marL="0">
-              <a:buNone/>
-            </a:pPr>
-            <a:r>
-              <a:rPr lang="en-US" sz="1400" i="1" dirty="0">
-                <a:solidFill>
-                  <a:schemeClr val="accent2"/>
-                </a:solidFill>
-              </a:rPr>
-              <a:t>[…]</a:t>
-            </a:r>
-            <a:pPr indent="0" marL="0">
-              <a:buNone/>
-            </a:pPr>
-            <a:r>
-              <a:rPr lang="en-US" sz="1400" dirty="0">
-                <a:solidFill>
-                  <a:schemeClr val="tx1"/>
-                </a:solidFill>
-              </a:rPr>
-              <a:t>; internal test split always with seed 0.</a:t>
-            </a:r>
-            <a:endParaRPr lang="en-US" sz="1400" dirty="0"/>
-          </a:p>
-        </p:txBody>
-      </p:sp>
-      <p:sp>
-        <p:nvSpPr>
-          <p:cNvPr id="25" name="Slide Number Placeholder 0"/>
-          <p:cNvSpPr>
-            <a:spLocks noGrp="1"/>
-          </p:cNvSpPr>
-          <p:nvPr>
-            <p:ph type="sldNum" sz="quarter" idx="4294967295"/>
-          </p:nvPr>
-        </p:nvSpPr>
-        <p:spPr>
-          <a:xfrm>
-            <a:off x="8138160" y="4736592"/>
-            <a:ext cx="548640" cy="274320"/>
-          </a:xfrm>
-          <a:prstGeom prst="rect">
-            <a:avLst/>
-          </a:prstGeom>
-          <a:extLst>
-            <a:ext uri="{C572A759-6A51-4108-AA02-DFA0A04FC94B}">
-              <ma14:wrappingTextBoxFlag xmlns:ma14="http://schemas.microsoft.com/office/mac/drawingml/2011/main" val="0"/>
-            </a:ext>
-          </a:extLst>
-        </p:spPr>
-        <p:txBody>
-          <a:bodyPr/>
-          <a:lstStyle>
-            <a:lvl1pPr>
-              <a:defRPr sz="1400">
-                <a:solidFill>
-                  <a:srgbClr val="5A6F86"/>
-                </a:solidFill>
-              </a:defRPr>
-            </a:lvl1pPr>
-          </a:lstStyle>
-          <a:p>
-            <a:pPr algn="r"/>
-            <a:fld id="{F7021451-1387-4CA6-816F-3879F97B5CBC}" type="slidenum">
-              <a:rPr b="0" lang="en-US"/>
-              <a:t>24</a:t>
             </a:fld>
             <a:endParaRPr lang="en-US"/>
           </a:p>
@@ -15568,7 +15168,7 @@
                   <a:schemeClr val="tx1"/>
                 </a:solidFill>
               </a:rPr>
-              <a:t>252 pytest tests, including a numerical gradient check</a:t>
+              <a:t>273 pytest tests, including a numerical gradient check</a:t>
             </a:r>
             <a:endParaRPr lang="en-US" sz="1400" dirty="0"/>
           </a:p>
@@ -16141,51 +15741,7 @@
                   <a:schemeClr val="tx1"/>
                 </a:solidFill>
               </a:rPr>
-              <a:t>Fully connected MLP of any depth; CUP: </a:t>
-            </a:r>
-            <a:pPr indent="0" marL="0">
-              <a:buNone/>
-            </a:pPr>
-            <a:r>
-              <a:rPr lang="en-US" sz="1400" i="1" dirty="0">
-                <a:solidFill>
-                  <a:schemeClr val="accent2"/>
-                </a:solidFill>
-              </a:rPr>
-              <a:t>[L]</a:t>
-            </a:r>
-            <a:pPr indent="0" marL="0">
-              <a:buNone/>
-            </a:pPr>
-            <a:r>
-              <a:rPr lang="en-US" sz="1400" dirty="0">
-                <a:solidFill>
-                  <a:schemeClr val="tx1"/>
-                </a:solidFill>
-              </a:rPr>
-              <a:t> hidden layers (</a:t>
-            </a:r>
-            <a:pPr indent="0" marL="0">
-              <a:buNone/>
-            </a:pPr>
-            <a:r>
-              <a:rPr lang="en-US" sz="1400" i="1" dirty="0">
-                <a:solidFill>
-                  <a:schemeClr val="accent2"/>
-                </a:solidFill>
-              </a:rPr>
-              <a:t>[units]</a:t>
-            </a:r>
-            <a:pPr indent="0" marL="0">
-              <a:buNone/>
-            </a:pPr>
-            <a:r>
-              <a:rPr lang="en-US" sz="1400" dirty="0">
-                <a:solidFill>
-                  <a:schemeClr val="tx1"/>
-                </a:solidFill>
-              </a:rPr>
-              <a:t>), 4 outputs</a:t>
+              <a:t>MLP of any depth; CUP: 2 hidden layers of 64 units, 4 linear outputs</a:t>
             </a:r>
             <a:endParaRPr lang="en-US" sz="1400" dirty="0"/>
           </a:p>
@@ -16329,18 +15885,7 @@
                   <a:schemeClr val="tx1"/>
                 </a:solidFill>
               </a:rPr>
-              <a:t>Back-propagation + SGD with classical or Nesterov momentum; CUP: </a:t>
-            </a:r>
-            <a:pPr indent="0" marL="0">
-              <a:buNone/>
-            </a:pPr>
-            <a:r>
-              <a:rPr lang="en-US" sz="1400" i="1" dirty="0">
-                <a:solidFill>
-                  <a:schemeClr val="accent2"/>
-                </a:solidFill>
-              </a:rPr>
-              <a:t>[Nesterov]</a:t>
+              <a:t>Backprop + SGD, classical or Nesterov momentum; CUP: classical, α 0.9</a:t>
             </a:r>
             <a:endParaRPr lang="en-US" sz="1400" dirty="0"/>
           </a:p>
@@ -16412,7 +15957,7 @@
                   <a:schemeClr val="tx1"/>
                 </a:solidFill>
               </a:rPr>
-              <a:t>Fixed, or variable with linear decay from η</a:t>
+              <a:t>Fixed, or linear decay from η</a:t>
             </a:r>
             <a:pPr indent="0" marL="0">
               <a:buNone/>
@@ -16456,18 +16001,7 @@
                   <a:schemeClr val="tx1"/>
                 </a:solidFill>
               </a:rPr>
-              <a:t> in τ epochs; CUP: </a:t>
-            </a:r>
-            <a:pPr indent="0" marL="0">
-              <a:buNone/>
-            </a:pPr>
-            <a:r>
-              <a:rPr lang="en-US" sz="1400" i="1" dirty="0">
-                <a:solidFill>
-                  <a:schemeClr val="accent2"/>
-                </a:solidFill>
-              </a:rPr>
-              <a:t>[fixed]</a:t>
+              <a:t> in τ epochs; CUP: fixed, η 0.01</a:t>
             </a:r>
             <a:endParaRPr lang="en-US" sz="1400" dirty="0"/>
           </a:p>
@@ -16539,29 +16073,7 @@
                   <a:schemeClr val="tx1"/>
                 </a:solidFill>
               </a:rPr>
-              <a:t>All three; CUP: mini-batch of </a:t>
-            </a:r>
-            <a:pPr indent="0" marL="0">
-              <a:buNone/>
-            </a:pPr>
-            <a:r>
-              <a:rPr lang="en-US" sz="1400" i="1" dirty="0">
-                <a:solidFill>
-                  <a:schemeClr val="accent2"/>
-                </a:solidFill>
-              </a:rPr>
-              <a:t>[32]</a:t>
-            </a:r>
-            <a:pPr indent="0" marL="0">
-              <a:buNone/>
-            </a:pPr>
-            <a:r>
-              <a:rPr lang="en-US" sz="1400" dirty="0">
-                <a:solidFill>
-                  <a:schemeClr val="tx1"/>
-                </a:solidFill>
-              </a:rPr>
-              <a:t>; MONK: Table 1</a:t>
+              <a:t>All three; CUP: full batch; MONK: Table 1</a:t>
             </a:r>
             <a:endParaRPr lang="en-US" sz="1400" dirty="0"/>
           </a:p>
@@ -16644,7 +16156,7 @@
                   <a:schemeClr val="accent2"/>
                 </a:solidFill>
               </a:rPr>
-              <a:t>[5]</a:t>
+              <a:t>10</a:t>
             </a:r>
             <a:pPr indent="0" marL="0">
               <a:buNone/>
@@ -16727,7 +16239,7 @@
                   <a:schemeClr val="tx1"/>
                 </a:solidFill>
               </a:rPr>
-              <a:t>L2 (Tikhonov) and L1 on the weights, not on the biases; CUP: L2</a:t>
+              <a:t>L2 (Tikhonov) and L1 on the weights, not on the biases; CUP: L2, λ 0.01</a:t>
             </a:r>
             <a:endParaRPr lang="en-US" sz="1400" dirty="0"/>
           </a:p>
@@ -16810,7 +16322,7 @@
                   <a:schemeClr val="accent2"/>
                 </a:solidFill>
               </a:rPr>
-              <a:t>[500]</a:t>
+              <a:t>100</a:t>
             </a:r>
             <a:pPr indent="0" marL="0">
               <a:buNone/>
@@ -17079,7 +16591,7 @@
                   <a:schemeClr val="tx1"/>
                 </a:solidFill>
               </a:rPr>
-              <a:t>Retraining on all 400 design patterns stops when TR MEE reaches the mean TR MEE at the best VL epoch of the CV</a:t>
+              <a:t>The retraining stops when TR MEE reaches the mean TR MEE at the best VL epoch of the CV</a:t>
             </a:r>
             <a:endParaRPr lang="en-US" sz="1400" dirty="0"/>
           </a:p>
@@ -17107,7 +16619,7 @@
                   <a:schemeClr val="tx1"/>
                 </a:solidFill>
               </a:rPr>
-              <a:t>a fold has 20% less data, so the same epoch count would not give the same fit</a:t>
+              <a:t>a fold trains on ≈267 patterns, the retraining on 400-500: equal epochs ≠ equal fit</a:t>
             </a:r>
             <a:endParaRPr lang="en-US" sz="1400" dirty="0"/>
           </a:p>
@@ -17210,7 +16722,7 @@
                   <a:schemeClr val="tx1"/>
                 </a:solidFill>
               </a:rPr>
-              <a:t>Every configuration trained with </a:t>
+              <a:t>Every configuration trained with several random inits on each fold (CUP: </a:t>
             </a:r>
             <a:pPr indent="0" marL="0">
               <a:buNone/>
@@ -17221,7 +16733,7 @@
                   <a:schemeClr val="accent2"/>
                 </a:solidFill>
               </a:rPr>
-              <a:t>[5]</a:t>
+              <a:t>10</a:t>
             </a:r>
             <a:pPr indent="0" marL="0">
               <a:buNone/>
@@ -17232,7 +16744,29 @@
                   <a:schemeClr val="tx1"/>
                 </a:solidFill>
               </a:rPr>
-              <a:t> random inits on each of the 5 folds; ranking on the mean</a:t>
+              <a:t> × </a:t>
+            </a:r>
+            <a:pPr indent="0" marL="0">
+              <a:buNone/>
+            </a:pPr>
+            <a:r>
+              <a:rPr lang="en-US" sz="1400" i="1" dirty="0">
+                <a:solidFill>
+                  <a:schemeClr val="accent2"/>
+                </a:solidFill>
+              </a:rPr>
+              <a:t>3</a:t>
+            </a:r>
+            <a:pPr indent="0" marL="0">
+              <a:buNone/>
+            </a:pPr>
+            <a:r>
+              <a:rPr lang="en-US" sz="1400" dirty="0">
+                <a:solidFill>
+                  <a:schemeClr val="tx1"/>
+                </a:solidFill>
+              </a:rPr>
+              <a:t> folds); ranking on the mean</a:t>
             </a:r>
             <a:endParaRPr lang="en-US" sz="1400" dirty="0"/>
           </a:p>
@@ -17560,29 +17094,7 @@
                   <a:schemeClr val="tx1"/>
                 </a:solidFill>
               </a:rPr>
-              <a:t>17 one-hot inputs → </a:t>
-            </a:r>
-            <a:pPr indent="0" marL="0">
-              <a:buNone/>
-            </a:pPr>
-            <a:r>
-              <a:rPr lang="en-US" sz="1400" i="1" dirty="0">
-                <a:solidFill>
-                  <a:schemeClr val="accent2"/>
-                </a:solidFill>
-              </a:rPr>
-              <a:t>[4]</a:t>
-            </a:r>
-            <a:pPr indent="0" marL="0">
-              <a:buNone/>
-            </a:pPr>
-            <a:r>
-              <a:rPr lang="en-US" sz="1400" dirty="0">
-                <a:solidFill>
-                  <a:schemeClr val="tx1"/>
-                </a:solidFill>
-              </a:rPr>
-              <a:t> tanh units → 1 sigmoid unit; MSE loss, Glorot init. Model selection: grid search with stratified hold-out (80% TR / 20% VL of the MONK training set); TS only for the final assessment.</a:t>
+              <a:t>17 one-hot inputs → 4 tanh units → 1 sigmoid unit; MSE loss, Glorot init. Model selection: grid search with stratified hold-out (80% TR / 20% VL); MONK 3 (reg.): 5-fold CV. TS only for the final assessment.</a:t>
             </a:r>
             <a:endParaRPr lang="en-US" sz="1400" dirty="0"/>
           </a:p>
@@ -17596,8 +17108,8 @@
         </p:nvSpPr>
         <p:spPr>
           <a:xfrm>
-            <a:off x="457200" y="1737360"/>
-            <a:ext cx="8229600" cy="320040"/>
+            <a:off x="457200" y="1719072"/>
+            <a:ext cx="8229600" cy="521208"/>
           </a:xfrm>
           <a:prstGeom prst="rect">
             <a:avLst/>
@@ -17618,29 +17130,7 @@
                   <a:schemeClr val="accent3"/>
                 </a:solidFill>
               </a:rPr>
-              <a:t>Table 1. Mean over </a:t>
-            </a:r>
-            <a:pPr indent="0" marL="0">
-              <a:buNone/>
-            </a:pPr>
-            <a:r>
-              <a:rPr lang="en-US" sz="1400" i="1" dirty="0">
-                <a:solidFill>
-                  <a:schemeClr val="accent2"/>
-                </a:solidFill>
-              </a:rPr>
-              <a:t>[50]</a:t>
-            </a:r>
-            <a:pPr indent="0" marL="0">
-              <a:buNone/>
-            </a:pPr>
-            <a:r>
-              <a:rPr lang="en-US" sz="1400" i="1" dirty="0">
-                <a:solidFill>
-                  <a:schemeClr val="accent3"/>
-                </a:solidFill>
-              </a:rPr>
-              <a:t> random inits (MSE without penalty); N = Nesterov, mb = mini-batch.</a:t>
+              <a:t>Table 1. Mean ± std over 50 inits, MSE without penalty. N = Nesterov; CV stop = retraining up to the TR-MSE target of the CV.</a:t>
             </a:r>
             <a:endParaRPr lang="en-US" sz="1400" dirty="0"/>
           </a:p>
@@ -17661,7 +17151,7 @@
           </p:nvPr>
         </p:nvGraphicFramePr>
         <p:xfrm>
-          <a:off x="457200" y="2103120"/>
+          <a:off x="457200" y="2240280"/>
           <a:ext cx="8229600" cy="914400"/>
         </p:xfrm>
         <a:graphic>
@@ -17669,10 +17159,12 @@
             <a:tbl>
               <a:tblPr/>
               <a:tblGrid>
-                <a:gridCol w="1325880"/>
-                <a:gridCol w="3520440"/>
-                <a:gridCol w="1691640"/>
-                <a:gridCol w="1691640"/>
+                <a:gridCol w="1188720"/>
+                <a:gridCol w="2286000"/>
+                <a:gridCol w="1188720"/>
+                <a:gridCol w="1188720"/>
+                <a:gridCol w="1188720"/>
+                <a:gridCol w="1188720"/>
               </a:tblGrid>
               <a:tr h="384048">
                 <a:tc>
@@ -17811,7 +17303,7 @@
                             <a:schemeClr val="bg1"/>
                           </a:solidFill>
                         </a:rPr>
-                        <a:t>MSE (TR / TS)</a:t>
+                        <a:t>MSE TR</a:t>
                       </a:r>
                       <a:endParaRPr lang="en-US" sz="1400" dirty="0"/>
                     </a:p>
@@ -17872,7 +17364,129 @@
                             <a:schemeClr val="bg1"/>
                           </a:solidFill>
                         </a:rPr>
-                        <a:t>Accuracy % (TR / TS)</a:t>
+                        <a:t>MSE TS</a:t>
+                      </a:r>
+                      <a:endParaRPr lang="en-US" sz="1400" dirty="0"/>
+                    </a:p>
+                  </a:txBody>
+                  <a:tcPr marL="45720" marR="45720" marT="45720" marB="45720" anchor="ctr">
+                    <a:lnL w="9525" cap="flat" cmpd="sng" algn="ctr">
+                      <a:solidFill>
+                        <a:srgbClr val="9DB0C6"/>
+                      </a:solidFill>
+                      <a:prstDash val="solid"/>
+                      <a:round/>
+                      <a:headEnd type="none" w="med" len="med"/>
+                      <a:tailEnd type="none" w="med" len="med"/>
+                    </a:lnL>
+                    <a:lnR w="9525" cap="flat" cmpd="sng" algn="ctr">
+                      <a:solidFill>
+                        <a:srgbClr val="9DB0C6"/>
+                      </a:solidFill>
+                      <a:prstDash val="solid"/>
+                      <a:round/>
+                      <a:headEnd type="none" w="med" len="med"/>
+                      <a:tailEnd type="none" w="med" len="med"/>
+                    </a:lnR>
+                    <a:lnT w="9525" cap="flat" cmpd="sng" algn="ctr">
+                      <a:solidFill>
+                        <a:srgbClr val="9DB0C6"/>
+                      </a:solidFill>
+                      <a:prstDash val="solid"/>
+                      <a:round/>
+                      <a:headEnd type="none" w="med" len="med"/>
+                      <a:tailEnd type="none" w="med" len="med"/>
+                    </a:lnT>
+                    <a:lnB w="9525" cap="flat" cmpd="sng" algn="ctr">
+                      <a:solidFill>
+                        <a:srgbClr val="9DB0C6"/>
+                      </a:solidFill>
+                      <a:prstDash val="solid"/>
+                      <a:round/>
+                      <a:headEnd type="none" w="med" len="med"/>
+                      <a:tailEnd type="none" w="med" len="med"/>
+                    </a:lnB>
+                    <a:solidFill>
+                      <a:schemeClr val="tx2"/>
+                    </a:solidFill>
+                  </a:tcPr>
+                </a:tc>
+                <a:tc>
+                  <a:txBody>
+                    <a:bodyPr/>
+                    <a:lstStyle/>
+                    <a:p>
+                      <a:pPr indent="0" marL="0">
+                        <a:buNone/>
+                      </a:pPr>
+                      <a:r>
+                        <a:rPr lang="en-US" sz="1400" b="1" dirty="0">
+                          <a:solidFill>
+                            <a:schemeClr val="bg1"/>
+                          </a:solidFill>
+                        </a:rPr>
+                        <a:t>Acc. TR (%)</a:t>
+                      </a:r>
+                      <a:endParaRPr lang="en-US" sz="1400" dirty="0"/>
+                    </a:p>
+                  </a:txBody>
+                  <a:tcPr marL="45720" marR="45720" marT="45720" marB="45720" anchor="ctr">
+                    <a:lnL w="9525" cap="flat" cmpd="sng" algn="ctr">
+                      <a:solidFill>
+                        <a:srgbClr val="9DB0C6"/>
+                      </a:solidFill>
+                      <a:prstDash val="solid"/>
+                      <a:round/>
+                      <a:headEnd type="none" w="med" len="med"/>
+                      <a:tailEnd type="none" w="med" len="med"/>
+                    </a:lnL>
+                    <a:lnR w="9525" cap="flat" cmpd="sng" algn="ctr">
+                      <a:solidFill>
+                        <a:srgbClr val="9DB0C6"/>
+                      </a:solidFill>
+                      <a:prstDash val="solid"/>
+                      <a:round/>
+                      <a:headEnd type="none" w="med" len="med"/>
+                      <a:tailEnd type="none" w="med" len="med"/>
+                    </a:lnR>
+                    <a:lnT w="9525" cap="flat" cmpd="sng" algn="ctr">
+                      <a:solidFill>
+                        <a:srgbClr val="9DB0C6"/>
+                      </a:solidFill>
+                      <a:prstDash val="solid"/>
+                      <a:round/>
+                      <a:headEnd type="none" w="med" len="med"/>
+                      <a:tailEnd type="none" w="med" len="med"/>
+                    </a:lnT>
+                    <a:lnB w="9525" cap="flat" cmpd="sng" algn="ctr">
+                      <a:solidFill>
+                        <a:srgbClr val="9DB0C6"/>
+                      </a:solidFill>
+                      <a:prstDash val="solid"/>
+                      <a:round/>
+                      <a:headEnd type="none" w="med" len="med"/>
+                      <a:tailEnd type="none" w="med" len="med"/>
+                    </a:lnB>
+                    <a:solidFill>
+                      <a:schemeClr val="tx2"/>
+                    </a:solidFill>
+                  </a:tcPr>
+                </a:tc>
+                <a:tc>
+                  <a:txBody>
+                    <a:bodyPr/>
+                    <a:lstStyle/>
+                    <a:p>
+                      <a:pPr indent="0" marL="0">
+                        <a:buNone/>
+                      </a:pPr>
+                      <a:r>
+                        <a:rPr lang="en-US" sz="1400" b="1" dirty="0">
+                          <a:solidFill>
+                            <a:schemeClr val="bg1"/>
+                          </a:solidFill>
+                        </a:rPr>
+                        <a:t>Acc. TS (%)</a:t>
                       </a:r>
                       <a:endParaRPr lang="en-US" sz="1400" dirty="0"/>
                     </a:p>
@@ -17991,12 +17605,12 @@
                         <a:buNone/>
                       </a:pPr>
                       <a:r>
-                        <a:rPr lang="en-US" sz="1400" i="1" dirty="0">
+                        <a:rPr lang="en-US" sz="1400" dirty="0">
                           <a:solidFill>
-                            <a:schemeClr val="accent2"/>
+                            <a:schemeClr val="tx1"/>
                           </a:solidFill>
                         </a:rPr>
-                        <a:t>4, η 0.5, α 0.7 N, mb 6, 160 ep</a:t>
+                        <a:t>4, η 0.7, batch, 1400 ep</a:t>
                       </a:r>
                       <a:endParaRPr lang="en-US" sz="1400" dirty="0"/>
                     </a:p>
@@ -18052,12 +17666,12 @@
                         <a:buNone/>
                       </a:pPr>
                       <a:r>
-                        <a:rPr lang="en-US" sz="1400" i="1" dirty="0">
+                        <a:rPr lang="en-US" sz="1400" dirty="0">
                           <a:solidFill>
-                            <a:schemeClr val="accent2"/>
+                            <a:schemeClr val="tx1"/>
                           </a:solidFill>
                         </a:rPr>
-                        <a:t>[…] / […]</a:t>
+                        <a:t>0.005 ± 0.015</a:t>
                       </a:r>
                       <a:endParaRPr lang="en-US" sz="1400" dirty="0"/>
                     </a:p>
@@ -18113,12 +17727,134 @@
                         <a:buNone/>
                       </a:pPr>
                       <a:r>
-                        <a:rPr lang="en-US" sz="1400" i="1" dirty="0">
+                        <a:rPr lang="en-US" sz="1400" dirty="0">
                           <a:solidFill>
-                            <a:schemeClr val="accent2"/>
+                            <a:schemeClr val="tx1"/>
                           </a:solidFill>
                         </a:rPr>
-                        <a:t>[…] / […]</a:t>
+                        <a:t>0.009 ± 0.019</a:t>
+                      </a:r>
+                      <a:endParaRPr lang="en-US" sz="1400" dirty="0"/>
+                    </a:p>
+                  </a:txBody>
+                  <a:tcPr marL="45720" marR="45720" marT="45720" marB="45720" anchor="ctr">
+                    <a:lnL w="9525" cap="flat" cmpd="sng" algn="ctr">
+                      <a:solidFill>
+                        <a:srgbClr val="9DB0C6"/>
+                      </a:solidFill>
+                      <a:prstDash val="solid"/>
+                      <a:round/>
+                      <a:headEnd type="none" w="med" len="med"/>
+                      <a:tailEnd type="none" w="med" len="med"/>
+                    </a:lnL>
+                    <a:lnR w="9525" cap="flat" cmpd="sng" algn="ctr">
+                      <a:solidFill>
+                        <a:srgbClr val="9DB0C6"/>
+                      </a:solidFill>
+                      <a:prstDash val="solid"/>
+                      <a:round/>
+                      <a:headEnd type="none" w="med" len="med"/>
+                      <a:tailEnd type="none" w="med" len="med"/>
+                    </a:lnR>
+                    <a:lnT w="9525" cap="flat" cmpd="sng" algn="ctr">
+                      <a:solidFill>
+                        <a:srgbClr val="9DB0C6"/>
+                      </a:solidFill>
+                      <a:prstDash val="solid"/>
+                      <a:round/>
+                      <a:headEnd type="none" w="med" len="med"/>
+                      <a:tailEnd type="none" w="med" len="med"/>
+                    </a:lnT>
+                    <a:lnB w="9525" cap="flat" cmpd="sng" algn="ctr">
+                      <a:solidFill>
+                        <a:srgbClr val="9DB0C6"/>
+                      </a:solidFill>
+                      <a:prstDash val="solid"/>
+                      <a:round/>
+                      <a:headEnd type="none" w="med" len="med"/>
+                      <a:tailEnd type="none" w="med" len="med"/>
+                    </a:lnB>
+                    <a:solidFill>
+                      <a:schemeClr val="bg1"/>
+                    </a:solidFill>
+                  </a:tcPr>
+                </a:tc>
+                <a:tc>
+                  <a:txBody>
+                    <a:bodyPr/>
+                    <a:lstStyle/>
+                    <a:p>
+                      <a:pPr indent="0" marL="0">
+                        <a:buNone/>
+                      </a:pPr>
+                      <a:r>
+                        <a:rPr lang="en-US" sz="1400" dirty="0">
+                          <a:solidFill>
+                            <a:schemeClr val="tx1"/>
+                          </a:solidFill>
+                        </a:rPr>
+                        <a:t>99.6 ± 1.5</a:t>
+                      </a:r>
+                      <a:endParaRPr lang="en-US" sz="1400" dirty="0"/>
+                    </a:p>
+                  </a:txBody>
+                  <a:tcPr marL="45720" marR="45720" marT="45720" marB="45720" anchor="ctr">
+                    <a:lnL w="9525" cap="flat" cmpd="sng" algn="ctr">
+                      <a:solidFill>
+                        <a:srgbClr val="9DB0C6"/>
+                      </a:solidFill>
+                      <a:prstDash val="solid"/>
+                      <a:round/>
+                      <a:headEnd type="none" w="med" len="med"/>
+                      <a:tailEnd type="none" w="med" len="med"/>
+                    </a:lnL>
+                    <a:lnR w="9525" cap="flat" cmpd="sng" algn="ctr">
+                      <a:solidFill>
+                        <a:srgbClr val="9DB0C6"/>
+                      </a:solidFill>
+                      <a:prstDash val="solid"/>
+                      <a:round/>
+                      <a:headEnd type="none" w="med" len="med"/>
+                      <a:tailEnd type="none" w="med" len="med"/>
+                    </a:lnR>
+                    <a:lnT w="9525" cap="flat" cmpd="sng" algn="ctr">
+                      <a:solidFill>
+                        <a:srgbClr val="9DB0C6"/>
+                      </a:solidFill>
+                      <a:prstDash val="solid"/>
+                      <a:round/>
+                      <a:headEnd type="none" w="med" len="med"/>
+                      <a:tailEnd type="none" w="med" len="med"/>
+                    </a:lnT>
+                    <a:lnB w="9525" cap="flat" cmpd="sng" algn="ctr">
+                      <a:solidFill>
+                        <a:srgbClr val="9DB0C6"/>
+                      </a:solidFill>
+                      <a:prstDash val="solid"/>
+                      <a:round/>
+                      <a:headEnd type="none" w="med" len="med"/>
+                      <a:tailEnd type="none" w="med" len="med"/>
+                    </a:lnB>
+                    <a:solidFill>
+                      <a:schemeClr val="bg1"/>
+                    </a:solidFill>
+                  </a:tcPr>
+                </a:tc>
+                <a:tc>
+                  <a:txBody>
+                    <a:bodyPr/>
+                    <a:lstStyle/>
+                    <a:p>
+                      <a:pPr indent="0" marL="0">
+                        <a:buNone/>
+                      </a:pPr>
+                      <a:r>
+                        <a:rPr lang="en-US" sz="1400" dirty="0">
+                          <a:solidFill>
+                            <a:schemeClr val="tx1"/>
+                          </a:solidFill>
+                        </a:rPr>
+                        <a:t>99.3 ± 2.0</a:t>
                       </a:r>
                       <a:endParaRPr lang="en-US" sz="1400" dirty="0"/>
                     </a:p>
@@ -18237,12 +17973,12 @@
                         <a:buNone/>
                       </a:pPr>
                       <a:r>
-                        <a:rPr lang="en-US" sz="1400" i="1" dirty="0">
+                        <a:rPr lang="en-US" sz="1400" dirty="0">
                           <a:solidFill>
-                            <a:schemeClr val="accent2"/>
+                            <a:schemeClr val="tx1"/>
                           </a:solidFill>
                         </a:rPr>
-                        <a:t>4, η 0.0075, α 0.9 N, λ 5e-4, on-line, 150 ep</a:t>
+                        <a:t>4, η 0.08, α 0.9 N, on-line, 71 ep</a:t>
                       </a:r>
                       <a:endParaRPr lang="en-US" sz="1400" dirty="0"/>
                     </a:p>
@@ -18298,12 +18034,12 @@
                         <a:buNone/>
                       </a:pPr>
                       <a:r>
-                        <a:rPr lang="en-US" sz="1400" i="1" dirty="0">
+                        <a:rPr lang="en-US" sz="1400" dirty="0">
                           <a:solidFill>
-                            <a:schemeClr val="accent2"/>
+                            <a:schemeClr val="tx1"/>
                           </a:solidFill>
                         </a:rPr>
-                        <a:t>[…] / […]</a:t>
+                        <a:t>0.002 ± 0.008</a:t>
                       </a:r>
                       <a:endParaRPr lang="en-US" sz="1400" dirty="0"/>
                     </a:p>
@@ -18359,12 +18095,134 @@
                         <a:buNone/>
                       </a:pPr>
                       <a:r>
-                        <a:rPr lang="en-US" sz="1400" i="1" dirty="0">
+                        <a:rPr lang="en-US" sz="1400" dirty="0">
                           <a:solidFill>
-                            <a:schemeClr val="accent2"/>
+                            <a:schemeClr val="tx1"/>
                           </a:solidFill>
                         </a:rPr>
-                        <a:t>[…] / […]</a:t>
+                        <a:t>0.004 ± 0.013</a:t>
+                      </a:r>
+                      <a:endParaRPr lang="en-US" sz="1400" dirty="0"/>
+                    </a:p>
+                  </a:txBody>
+                  <a:tcPr marL="45720" marR="45720" marT="45720" marB="45720" anchor="ctr">
+                    <a:lnL w="9525" cap="flat" cmpd="sng" algn="ctr">
+                      <a:solidFill>
+                        <a:srgbClr val="9DB0C6"/>
+                      </a:solidFill>
+                      <a:prstDash val="solid"/>
+                      <a:round/>
+                      <a:headEnd type="none" w="med" len="med"/>
+                      <a:tailEnd type="none" w="med" len="med"/>
+                    </a:lnL>
+                    <a:lnR w="9525" cap="flat" cmpd="sng" algn="ctr">
+                      <a:solidFill>
+                        <a:srgbClr val="9DB0C6"/>
+                      </a:solidFill>
+                      <a:prstDash val="solid"/>
+                      <a:round/>
+                      <a:headEnd type="none" w="med" len="med"/>
+                      <a:tailEnd type="none" w="med" len="med"/>
+                    </a:lnR>
+                    <a:lnT w="9525" cap="flat" cmpd="sng" algn="ctr">
+                      <a:solidFill>
+                        <a:srgbClr val="9DB0C6"/>
+                      </a:solidFill>
+                      <a:prstDash val="solid"/>
+                      <a:round/>
+                      <a:headEnd type="none" w="med" len="med"/>
+                      <a:tailEnd type="none" w="med" len="med"/>
+                    </a:lnT>
+                    <a:lnB w="9525" cap="flat" cmpd="sng" algn="ctr">
+                      <a:solidFill>
+                        <a:srgbClr val="9DB0C6"/>
+                      </a:solidFill>
+                      <a:prstDash val="solid"/>
+                      <a:round/>
+                      <a:headEnd type="none" w="med" len="med"/>
+                      <a:tailEnd type="none" w="med" len="med"/>
+                    </a:lnB>
+                    <a:solidFill>
+                      <a:schemeClr val="bg2"/>
+                    </a:solidFill>
+                  </a:tcPr>
+                </a:tc>
+                <a:tc>
+                  <a:txBody>
+                    <a:bodyPr/>
+                    <a:lstStyle/>
+                    <a:p>
+                      <a:pPr indent="0" marL="0">
+                        <a:buNone/>
+                      </a:pPr>
+                      <a:r>
+                        <a:rPr lang="en-US" sz="1400" dirty="0">
+                          <a:solidFill>
+                            <a:schemeClr val="tx1"/>
+                          </a:solidFill>
+                        </a:rPr>
+                        <a:t>99.8 ± 1.0</a:t>
+                      </a:r>
+                      <a:endParaRPr lang="en-US" sz="1400" dirty="0"/>
+                    </a:p>
+                  </a:txBody>
+                  <a:tcPr marL="45720" marR="45720" marT="45720" marB="45720" anchor="ctr">
+                    <a:lnL w="9525" cap="flat" cmpd="sng" algn="ctr">
+                      <a:solidFill>
+                        <a:srgbClr val="9DB0C6"/>
+                      </a:solidFill>
+                      <a:prstDash val="solid"/>
+                      <a:round/>
+                      <a:headEnd type="none" w="med" len="med"/>
+                      <a:tailEnd type="none" w="med" len="med"/>
+                    </a:lnL>
+                    <a:lnR w="9525" cap="flat" cmpd="sng" algn="ctr">
+                      <a:solidFill>
+                        <a:srgbClr val="9DB0C6"/>
+                      </a:solidFill>
+                      <a:prstDash val="solid"/>
+                      <a:round/>
+                      <a:headEnd type="none" w="med" len="med"/>
+                      <a:tailEnd type="none" w="med" len="med"/>
+                    </a:lnR>
+                    <a:lnT w="9525" cap="flat" cmpd="sng" algn="ctr">
+                      <a:solidFill>
+                        <a:srgbClr val="9DB0C6"/>
+                      </a:solidFill>
+                      <a:prstDash val="solid"/>
+                      <a:round/>
+                      <a:headEnd type="none" w="med" len="med"/>
+                      <a:tailEnd type="none" w="med" len="med"/>
+                    </a:lnT>
+                    <a:lnB w="9525" cap="flat" cmpd="sng" algn="ctr">
+                      <a:solidFill>
+                        <a:srgbClr val="9DB0C6"/>
+                      </a:solidFill>
+                      <a:prstDash val="solid"/>
+                      <a:round/>
+                      <a:headEnd type="none" w="med" len="med"/>
+                      <a:tailEnd type="none" w="med" len="med"/>
+                    </a:lnB>
+                    <a:solidFill>
+                      <a:schemeClr val="bg2"/>
+                    </a:solidFill>
+                  </a:tcPr>
+                </a:tc>
+                <a:tc>
+                  <a:txBody>
+                    <a:bodyPr/>
+                    <a:lstStyle/>
+                    <a:p>
+                      <a:pPr indent="0" marL="0">
+                        <a:buNone/>
+                      </a:pPr>
+                      <a:r>
+                        <a:rPr lang="en-US" sz="1400" dirty="0">
+                          <a:solidFill>
+                            <a:schemeClr val="tx1"/>
+                          </a:solidFill>
+                        </a:rPr>
+                        <a:t>99.6 ± 1.5</a:t>
                       </a:r>
                       <a:endParaRPr lang="en-US" sz="1400" dirty="0"/>
                     </a:p>
@@ -18483,9 +18341,9 @@
                         <a:buNone/>
                       </a:pPr>
                       <a:r>
-                        <a:rPr lang="en-US" sz="1400" i="1" dirty="0">
+                        <a:rPr lang="en-US" sz="1400" dirty="0">
                           <a:solidFill>
-                            <a:schemeClr val="accent2"/>
+                            <a:schemeClr val="tx1"/>
                           </a:solidFill>
                         </a:rPr>
                         <a:t>4, η 0.5, batch, 300 ep</a:t>
@@ -18544,12 +18402,12 @@
                         <a:buNone/>
                       </a:pPr>
                       <a:r>
-                        <a:rPr lang="en-US" sz="1400" i="1" dirty="0">
+                        <a:rPr lang="en-US" sz="1400" dirty="0">
                           <a:solidFill>
-                            <a:schemeClr val="accent2"/>
+                            <a:schemeClr val="tx1"/>
                           </a:solidFill>
                         </a:rPr>
-                        <a:t>[…] / […]</a:t>
+                        <a:t>0.045 ± 0.002</a:t>
                       </a:r>
                       <a:endParaRPr lang="en-US" sz="1400" dirty="0"/>
                     </a:p>
@@ -18605,12 +18463,134 @@
                         <a:buNone/>
                       </a:pPr>
                       <a:r>
-                        <a:rPr lang="en-US" sz="1400" i="1" dirty="0">
+                        <a:rPr lang="en-US" sz="1400" dirty="0">
                           <a:solidFill>
-                            <a:schemeClr val="accent2"/>
+                            <a:schemeClr val="tx1"/>
                           </a:solidFill>
                         </a:rPr>
-                        <a:t>[…] / […]</a:t>
+                        <a:t>0.042 ± 0.004</a:t>
+                      </a:r>
+                      <a:endParaRPr lang="en-US" sz="1400" dirty="0"/>
+                    </a:p>
+                  </a:txBody>
+                  <a:tcPr marL="45720" marR="45720" marT="45720" marB="45720" anchor="ctr">
+                    <a:lnL w="9525" cap="flat" cmpd="sng" algn="ctr">
+                      <a:solidFill>
+                        <a:srgbClr val="9DB0C6"/>
+                      </a:solidFill>
+                      <a:prstDash val="solid"/>
+                      <a:round/>
+                      <a:headEnd type="none" w="med" len="med"/>
+                      <a:tailEnd type="none" w="med" len="med"/>
+                    </a:lnL>
+                    <a:lnR w="9525" cap="flat" cmpd="sng" algn="ctr">
+                      <a:solidFill>
+                        <a:srgbClr val="9DB0C6"/>
+                      </a:solidFill>
+                      <a:prstDash val="solid"/>
+                      <a:round/>
+                      <a:headEnd type="none" w="med" len="med"/>
+                      <a:tailEnd type="none" w="med" len="med"/>
+                    </a:lnR>
+                    <a:lnT w="9525" cap="flat" cmpd="sng" algn="ctr">
+                      <a:solidFill>
+                        <a:srgbClr val="9DB0C6"/>
+                      </a:solidFill>
+                      <a:prstDash val="solid"/>
+                      <a:round/>
+                      <a:headEnd type="none" w="med" len="med"/>
+                      <a:tailEnd type="none" w="med" len="med"/>
+                    </a:lnT>
+                    <a:lnB w="9525" cap="flat" cmpd="sng" algn="ctr">
+                      <a:solidFill>
+                        <a:srgbClr val="9DB0C6"/>
+                      </a:solidFill>
+                      <a:prstDash val="solid"/>
+                      <a:round/>
+                      <a:headEnd type="none" w="med" len="med"/>
+                      <a:tailEnd type="none" w="med" len="med"/>
+                    </a:lnB>
+                    <a:solidFill>
+                      <a:schemeClr val="bg1"/>
+                    </a:solidFill>
+                  </a:tcPr>
+                </a:tc>
+                <a:tc>
+                  <a:txBody>
+                    <a:bodyPr/>
+                    <a:lstStyle/>
+                    <a:p>
+                      <a:pPr indent="0" marL="0">
+                        <a:buNone/>
+                      </a:pPr>
+                      <a:r>
+                        <a:rPr lang="en-US" sz="1400" dirty="0">
+                          <a:solidFill>
+                            <a:schemeClr val="tx1"/>
+                          </a:solidFill>
+                        </a:rPr>
+                        <a:t>94.9 ± 0.4</a:t>
+                      </a:r>
+                      <a:endParaRPr lang="en-US" sz="1400" dirty="0"/>
+                    </a:p>
+                  </a:txBody>
+                  <a:tcPr marL="45720" marR="45720" marT="45720" marB="45720" anchor="ctr">
+                    <a:lnL w="9525" cap="flat" cmpd="sng" algn="ctr">
+                      <a:solidFill>
+                        <a:srgbClr val="9DB0C6"/>
+                      </a:solidFill>
+                      <a:prstDash val="solid"/>
+                      <a:round/>
+                      <a:headEnd type="none" w="med" len="med"/>
+                      <a:tailEnd type="none" w="med" len="med"/>
+                    </a:lnL>
+                    <a:lnR w="9525" cap="flat" cmpd="sng" algn="ctr">
+                      <a:solidFill>
+                        <a:srgbClr val="9DB0C6"/>
+                      </a:solidFill>
+                      <a:prstDash val="solid"/>
+                      <a:round/>
+                      <a:headEnd type="none" w="med" len="med"/>
+                      <a:tailEnd type="none" w="med" len="med"/>
+                    </a:lnR>
+                    <a:lnT w="9525" cap="flat" cmpd="sng" algn="ctr">
+                      <a:solidFill>
+                        <a:srgbClr val="9DB0C6"/>
+                      </a:solidFill>
+                      <a:prstDash val="solid"/>
+                      <a:round/>
+                      <a:headEnd type="none" w="med" len="med"/>
+                      <a:tailEnd type="none" w="med" len="med"/>
+                    </a:lnT>
+                    <a:lnB w="9525" cap="flat" cmpd="sng" algn="ctr">
+                      <a:solidFill>
+                        <a:srgbClr val="9DB0C6"/>
+                      </a:solidFill>
+                      <a:prstDash val="solid"/>
+                      <a:round/>
+                      <a:headEnd type="none" w="med" len="med"/>
+                      <a:tailEnd type="none" w="med" len="med"/>
+                    </a:lnB>
+                    <a:solidFill>
+                      <a:schemeClr val="bg1"/>
+                    </a:solidFill>
+                  </a:tcPr>
+                </a:tc>
+                <a:tc>
+                  <a:txBody>
+                    <a:bodyPr/>
+                    <a:lstStyle/>
+                    <a:p>
+                      <a:pPr indent="0" marL="0">
+                        <a:buNone/>
+                      </a:pPr>
+                      <a:r>
+                        <a:rPr lang="en-US" sz="1400" dirty="0">
+                          <a:solidFill>
+                            <a:schemeClr val="tx1"/>
+                          </a:solidFill>
+                        </a:rPr>
+                        <a:t>95.8 ± 0.5</a:t>
                       </a:r>
                       <a:endParaRPr lang="en-US" sz="1400" dirty="0"/>
                     </a:p>
@@ -18729,12 +18709,12 @@
                         <a:buNone/>
                       </a:pPr>
                       <a:r>
-                        <a:rPr lang="en-US" sz="1400" i="1" dirty="0">
+                        <a:rPr lang="en-US" sz="1400" dirty="0">
                           <a:solidFill>
-                            <a:schemeClr val="accent2"/>
+                            <a:schemeClr val="tx1"/>
                           </a:solidFill>
                         </a:rPr>
-                        <a:t>[…]</a:t>
+                        <a:t>4, η 0.7, α 0.9, λ 0.01, batch, CV stop</a:t>
                       </a:r>
                       <a:endParaRPr lang="en-US" sz="1400" dirty="0"/>
                     </a:p>
@@ -18790,12 +18770,12 @@
                         <a:buNone/>
                       </a:pPr>
                       <a:r>
-                        <a:rPr lang="en-US" sz="1400" i="1" dirty="0">
+                        <a:rPr lang="en-US" sz="1400" dirty="0">
                           <a:solidFill>
-                            <a:schemeClr val="accent2"/>
+                            <a:schemeClr val="tx1"/>
                           </a:solidFill>
                         </a:rPr>
-                        <a:t>[…] / […]</a:t>
+                        <a:t>0.069 ± 0.006</a:t>
                       </a:r>
                       <a:endParaRPr lang="en-US" sz="1400" dirty="0"/>
                     </a:p>
@@ -18851,12 +18831,134 @@
                         <a:buNone/>
                       </a:pPr>
                       <a:r>
-                        <a:rPr lang="en-US" sz="1400" i="1" dirty="0">
+                        <a:rPr lang="en-US" sz="1400" dirty="0">
                           <a:solidFill>
-                            <a:schemeClr val="accent2"/>
+                            <a:schemeClr val="tx1"/>
                           </a:solidFill>
                         </a:rPr>
-                        <a:t>[…] / […]</a:t>
+                        <a:t>0.055 ± 0.007</a:t>
+                      </a:r>
+                      <a:endParaRPr lang="en-US" sz="1400" dirty="0"/>
+                    </a:p>
+                  </a:txBody>
+                  <a:tcPr marL="45720" marR="45720" marT="45720" marB="45720" anchor="ctr">
+                    <a:lnL w="9525" cap="flat" cmpd="sng" algn="ctr">
+                      <a:solidFill>
+                        <a:srgbClr val="9DB0C6"/>
+                      </a:solidFill>
+                      <a:prstDash val="solid"/>
+                      <a:round/>
+                      <a:headEnd type="none" w="med" len="med"/>
+                      <a:tailEnd type="none" w="med" len="med"/>
+                    </a:lnL>
+                    <a:lnR w="9525" cap="flat" cmpd="sng" algn="ctr">
+                      <a:solidFill>
+                        <a:srgbClr val="9DB0C6"/>
+                      </a:solidFill>
+                      <a:prstDash val="solid"/>
+                      <a:round/>
+                      <a:headEnd type="none" w="med" len="med"/>
+                      <a:tailEnd type="none" w="med" len="med"/>
+                    </a:lnR>
+                    <a:lnT w="9525" cap="flat" cmpd="sng" algn="ctr">
+                      <a:solidFill>
+                        <a:srgbClr val="9DB0C6"/>
+                      </a:solidFill>
+                      <a:prstDash val="solid"/>
+                      <a:round/>
+                      <a:headEnd type="none" w="med" len="med"/>
+                      <a:tailEnd type="none" w="med" len="med"/>
+                    </a:lnT>
+                    <a:lnB w="9525" cap="flat" cmpd="sng" algn="ctr">
+                      <a:solidFill>
+                        <a:srgbClr val="9DB0C6"/>
+                      </a:solidFill>
+                      <a:prstDash val="solid"/>
+                      <a:round/>
+                      <a:headEnd type="none" w="med" len="med"/>
+                      <a:tailEnd type="none" w="med" len="med"/>
+                    </a:lnB>
+                    <a:solidFill>
+                      <a:schemeClr val="bg2"/>
+                    </a:solidFill>
+                  </a:tcPr>
+                </a:tc>
+                <a:tc>
+                  <a:txBody>
+                    <a:bodyPr/>
+                    <a:lstStyle/>
+                    <a:p>
+                      <a:pPr indent="0" marL="0">
+                        <a:buNone/>
+                      </a:pPr>
+                      <a:r>
+                        <a:rPr lang="en-US" sz="1400" dirty="0">
+                          <a:solidFill>
+                            <a:schemeClr val="tx1"/>
+                          </a:solidFill>
+                        </a:rPr>
+                        <a:t>93.4 ± 0.2</a:t>
+                      </a:r>
+                      <a:endParaRPr lang="en-US" sz="1400" dirty="0"/>
+                    </a:p>
+                  </a:txBody>
+                  <a:tcPr marL="45720" marR="45720" marT="45720" marB="45720" anchor="ctr">
+                    <a:lnL w="9525" cap="flat" cmpd="sng" algn="ctr">
+                      <a:solidFill>
+                        <a:srgbClr val="9DB0C6"/>
+                      </a:solidFill>
+                      <a:prstDash val="solid"/>
+                      <a:round/>
+                      <a:headEnd type="none" w="med" len="med"/>
+                      <a:tailEnd type="none" w="med" len="med"/>
+                    </a:lnL>
+                    <a:lnR w="9525" cap="flat" cmpd="sng" algn="ctr">
+                      <a:solidFill>
+                        <a:srgbClr val="9DB0C6"/>
+                      </a:solidFill>
+                      <a:prstDash val="solid"/>
+                      <a:round/>
+                      <a:headEnd type="none" w="med" len="med"/>
+                      <a:tailEnd type="none" w="med" len="med"/>
+                    </a:lnR>
+                    <a:lnT w="9525" cap="flat" cmpd="sng" algn="ctr">
+                      <a:solidFill>
+                        <a:srgbClr val="9DB0C6"/>
+                      </a:solidFill>
+                      <a:prstDash val="solid"/>
+                      <a:round/>
+                      <a:headEnd type="none" w="med" len="med"/>
+                      <a:tailEnd type="none" w="med" len="med"/>
+                    </a:lnT>
+                    <a:lnB w="9525" cap="flat" cmpd="sng" algn="ctr">
+                      <a:solidFill>
+                        <a:srgbClr val="9DB0C6"/>
+                      </a:solidFill>
+                      <a:prstDash val="solid"/>
+                      <a:round/>
+                      <a:headEnd type="none" w="med" len="med"/>
+                      <a:tailEnd type="none" w="med" len="med"/>
+                    </a:lnB>
+                    <a:solidFill>
+                      <a:schemeClr val="bg2"/>
+                    </a:solidFill>
+                  </a:tcPr>
+                </a:tc>
+                <a:tc>
+                  <a:txBody>
+                    <a:bodyPr/>
+                    <a:lstStyle/>
+                    <a:p>
+                      <a:pPr indent="0" marL="0">
+                        <a:buNone/>
+                      </a:pPr>
+                      <a:r>
+                        <a:rPr lang="en-US" sz="1400" dirty="0">
+                          <a:solidFill>
+                            <a:schemeClr val="tx1"/>
+                          </a:solidFill>
+                        </a:rPr>
+                        <a:t>97.1 ± 0.3</a:t>
                       </a:r>
                       <a:endParaRPr lang="en-US" sz="1400" dirty="0"/>
                     </a:p>
@@ -19016,16 +19118,40 @@
           </a:p>
         </p:txBody>
       </p:sp>
-      <p:sp>
-        <p:nvSpPr>
-          <p:cNvPr id="3" name="Text 1"/>
+      <p:pic>
+        <p:nvPicPr>
+          <p:cNvPr id="3" name="Image 0" descr="MONK undefined learning curves: MSE and accuracy">    </p:cNvPr>
+          <p:cNvPicPr>
+            <a:picLocks noChangeAspect="1"/>
+          </p:cNvPicPr>
+          <p:nvPr/>
+        </p:nvPicPr>
+        <p:blipFill>
+          <a:blip r:embed="rId1"/>
+          <a:stretch>
+            <a:fillRect/>
+          </a:stretch>
+        </p:blipFill>
+        <p:spPr>
+          <a:xfrm>
+            <a:off x="457200" y="960120"/>
+            <a:ext cx="5120640" cy="1691363"/>
+          </a:xfrm>
+          <a:prstGeom prst="rect">
+            <a:avLst/>
+          </a:prstGeom>
+        </p:spPr>
+      </p:pic>
+      <p:sp>
+        <p:nvSpPr>
+          <p:cNvPr id="4" name="Text 1"/>
           <p:cNvSpPr txBox="1"/>
           <p:nvPr/>
         </p:nvSpPr>
         <p:spPr>
           <a:xfrm>
-            <a:off x="457200" y="960120"/>
-            <a:ext cx="1188720" cy="1508760"/>
+            <a:off x="5806440" y="960120"/>
+            <a:ext cx="2880360" cy="1691363"/>
           </a:xfrm>
           <a:prstGeom prst="rect">
             <a:avLst/>
@@ -19038,6 +19164,9 @@
           <a:lstStyle/>
           <a:p>
             <a:pPr indent="0" marL="0">
+              <a:spcAft>
+                <a:spcPts val="400"/>
+              </a:spcAft>
               <a:buNone/>
             </a:pPr>
             <a:r>
@@ -19046,47 +19175,77 @@
                   <a:schemeClr val="tx2"/>
                 </a:solidFill>
               </a:rPr>
-              <a:t>MONK 1</a:t>
+              <a:t>MONK undefined</a:t>
             </a:r>
             <a:endParaRPr lang="en-US" sz="1400" dirty="0"/>
           </a:p>
+          <a:p>
+            <a:pPr indent="0" marL="0">
+              <a:spcAft>
+                <a:spcPts val="600"/>
+              </a:spcAft>
+              <a:buNone/>
+            </a:pPr>
+            <a:r>
+              <a:rPr lang="en-US" sz="1400" dirty="0">
+                <a:solidFill>
+                  <a:schemeClr val="tx1"/>
+                </a:solidFill>
+              </a:rPr>
+              <a:t>TS accuracy 99.3 ± 2.0%; 100% in 37 of 50 trials</a:t>
+            </a:r>
+            <a:endParaRPr lang="en-US" sz="1400" dirty="0"/>
+          </a:p>
+          <a:p>
+            <a:pPr indent="0" marL="0">
+              <a:buNone/>
+            </a:pPr>
+            <a:r>
+              <a:rPr lang="en-US" sz="1400" i="1" dirty="0">
+                <a:solidFill>
+                  <a:schemeClr val="accent3"/>
+                </a:solidFill>
+              </a:rPr>
+              <a:t>Fig. 1. Trial with median TS accuracy; training solid, test dashed.</a:t>
+            </a:r>
+            <a:endParaRPr lang="en-US" sz="1400" dirty="0"/>
+          </a:p>
         </p:txBody>
       </p:sp>
-      <p:sp>
-        <p:nvSpPr>
-          <p:cNvPr id="4" name="figure placeholder"/>
-          <p:cNvSpPr/>
+      <p:pic>
+        <p:nvPicPr>
+          <p:cNvPr id="5" name="Image 1" descr="MONK undefined learning curves: MSE and accuracy">    </p:cNvPr>
+          <p:cNvPicPr>
+            <a:picLocks noChangeAspect="1"/>
+          </p:cNvPicPr>
           <p:nvPr/>
-        </p:nvSpPr>
-        <p:spPr>
-          <a:xfrm>
-            <a:off x="1737360" y="960120"/>
-            <a:ext cx="6949440" cy="1508760"/>
+        </p:nvPicPr>
+        <p:blipFill>
+          <a:blip r:embed="rId2"/>
+          <a:stretch>
+            <a:fillRect/>
+          </a:stretch>
+        </p:blipFill>
+        <p:spPr>
+          <a:xfrm>
+            <a:off x="457200" y="2834640"/>
+            <a:ext cx="5120640" cy="1691363"/>
           </a:xfrm>
           <a:prstGeom prst="rect">
             <a:avLst/>
           </a:prstGeom>
-          <a:solidFill>
-            <a:schemeClr val="bg1"/>
-          </a:solidFill>
-          <a:ln w="15875">
-            <a:solidFill>
-              <a:srgbClr val="9DB0C6"/>
-            </a:solidFill>
-            <a:prstDash val="dash"/>
-          </a:ln>
-        </p:spPr>
-      </p:sp>
-      <p:sp>
-        <p:nvSpPr>
-          <p:cNvPr id="5" name="Text 3"/>
+        </p:spPr>
+      </p:pic>
+      <p:sp>
+        <p:nvSpPr>
+          <p:cNvPr id="6" name="Text 2"/>
           <p:cNvSpPr txBox="1"/>
           <p:nvPr/>
         </p:nvSpPr>
         <p:spPr>
           <a:xfrm>
-            <a:off x="1920240" y="960120"/>
-            <a:ext cx="6583680" cy="1508760"/>
+            <a:off x="5806440" y="2834640"/>
+            <a:ext cx="2880360" cy="1691363"/>
           </a:xfrm>
           <a:prstGeom prst="rect">
             <a:avLst/>
@@ -19098,149 +19257,50 @@
           <a:bodyPr wrap="square" lIns="635" tIns="635" rIns="635" bIns="635" rtlCol="0" anchor="ctr"/>
           <a:lstStyle/>
           <a:p>
-            <a:pPr algn="ctr" indent="0" marL="0">
+            <a:pPr indent="0" marL="0">
+              <a:spcAft>
+                <a:spcPts val="400"/>
+              </a:spcAft>
+              <a:buNone/>
+            </a:pPr>
+            <a:r>
+              <a:rPr lang="en-US" sz="1600" b="1" dirty="0">
+                <a:solidFill>
+                  <a:schemeClr val="tx2"/>
+                </a:solidFill>
+              </a:rPr>
+              <a:t>MONK undefined</a:t>
+            </a:r>
+            <a:endParaRPr lang="en-US" sz="1400" dirty="0"/>
+          </a:p>
+          <a:p>
+            <a:pPr indent="0" marL="0">
+              <a:spcAft>
+                <a:spcPts val="600"/>
+              </a:spcAft>
+              <a:buNone/>
+            </a:pPr>
+            <a:r>
+              <a:rPr lang="en-US" sz="1400" dirty="0">
+                <a:solidFill>
+                  <a:schemeClr val="tx1"/>
+                </a:solidFill>
+              </a:rPr>
+              <a:t>TS accuracy 99.6 ± 1.5%; 100% in 44 of 50 trials</a:t>
+            </a:r>
+            <a:endParaRPr lang="en-US" sz="1400" dirty="0"/>
+          </a:p>
+          <a:p>
+            <a:pPr indent="0" marL="0">
               <a:buNone/>
             </a:pPr>
             <a:r>
               <a:rPr lang="en-US" sz="1400" i="1" dirty="0">
                 <a:solidFill>
-                  <a:schemeClr val="accent2"/>
-                </a:solidFill>
-              </a:rPr>
-              <a:t>[MONK 1 plot: MSE (left) | accuracy (right), TR solid / TS dashed]</a:t>
-            </a:r>
-            <a:endParaRPr lang="en-US" sz="1400" dirty="0"/>
-          </a:p>
-        </p:txBody>
-      </p:sp>
-      <p:sp>
-        <p:nvSpPr>
-          <p:cNvPr id="6" name="Text 4"/>
-          <p:cNvSpPr txBox="1"/>
-          <p:nvPr/>
-        </p:nvSpPr>
-        <p:spPr>
-          <a:xfrm>
-            <a:off x="457200" y="2587752"/>
-            <a:ext cx="1188720" cy="1508760"/>
-          </a:xfrm>
-          <a:prstGeom prst="rect">
-            <a:avLst/>
-          </a:prstGeom>
-          <a:noFill/>
-          <a:ln/>
-        </p:spPr>
-        <p:txBody>
-          <a:bodyPr wrap="square" lIns="635" tIns="635" rIns="635" bIns="635" rtlCol="0" anchor="ctr"/>
-          <a:lstStyle/>
-          <a:p>
-            <a:pPr indent="0" marL="0">
-              <a:buNone/>
-            </a:pPr>
-            <a:r>
-              <a:rPr lang="en-US" sz="1600" b="1" dirty="0">
-                <a:solidFill>
-                  <a:schemeClr val="tx2"/>
-                </a:solidFill>
-              </a:rPr>
-              <a:t>MONK 2</a:t>
-            </a:r>
-            <a:endParaRPr lang="en-US" sz="1400" dirty="0"/>
-          </a:p>
-        </p:txBody>
-      </p:sp>
-      <p:sp>
-        <p:nvSpPr>
-          <p:cNvPr id="7" name="figure placeholder"/>
-          <p:cNvSpPr/>
-          <p:nvPr/>
-        </p:nvSpPr>
-        <p:spPr>
-          <a:xfrm>
-            <a:off x="1737360" y="2587752"/>
-            <a:ext cx="6949440" cy="1508760"/>
-          </a:xfrm>
-          <a:prstGeom prst="rect">
-            <a:avLst/>
-          </a:prstGeom>
-          <a:solidFill>
-            <a:schemeClr val="bg1"/>
-          </a:solidFill>
-          <a:ln w="15875">
-            <a:solidFill>
-              <a:srgbClr val="9DB0C6"/>
-            </a:solidFill>
-            <a:prstDash val="dash"/>
-          </a:ln>
-        </p:spPr>
-      </p:sp>
-      <p:sp>
-        <p:nvSpPr>
-          <p:cNvPr id="8" name="Text 6"/>
-          <p:cNvSpPr txBox="1"/>
-          <p:nvPr/>
-        </p:nvSpPr>
-        <p:spPr>
-          <a:xfrm>
-            <a:off x="1920240" y="2587752"/>
-            <a:ext cx="6583680" cy="1508760"/>
-          </a:xfrm>
-          <a:prstGeom prst="rect">
-            <a:avLst/>
-          </a:prstGeom>
-          <a:noFill/>
-          <a:ln/>
-        </p:spPr>
-        <p:txBody>
-          <a:bodyPr wrap="square" lIns="635" tIns="635" rIns="635" bIns="635" rtlCol="0" anchor="ctr"/>
-          <a:lstStyle/>
-          <a:p>
-            <a:pPr algn="ctr" indent="0" marL="0">
-              <a:buNone/>
-            </a:pPr>
-            <a:r>
-              <a:rPr lang="en-US" sz="1400" i="1" dirty="0">
-                <a:solidFill>
-                  <a:schemeClr val="accent2"/>
-                </a:solidFill>
-              </a:rPr>
-              <a:t>[MONK 2 plot: MSE (left) | accuracy (right), TR solid / TS dashed]</a:t>
-            </a:r>
-            <a:endParaRPr lang="en-US" sz="1400" dirty="0"/>
-          </a:p>
-        </p:txBody>
-      </p:sp>
-      <p:sp>
-        <p:nvSpPr>
-          <p:cNvPr id="9" name="Text 7"/>
-          <p:cNvSpPr txBox="1"/>
-          <p:nvPr/>
-        </p:nvSpPr>
-        <p:spPr>
-          <a:xfrm>
-            <a:off x="457200" y="4160520"/>
-            <a:ext cx="8229600" cy="502920"/>
-          </a:xfrm>
-          <a:prstGeom prst="rect">
-            <a:avLst/>
-          </a:prstGeom>
-          <a:noFill/>
-          <a:ln/>
-        </p:spPr>
-        <p:txBody>
-          <a:bodyPr wrap="square" lIns="635" tIns="635" rIns="635" bIns="635" rtlCol="0" anchor="t"/>
-          <a:lstStyle/>
-          <a:p>
-            <a:pPr indent="0" marL="0">
-              <a:buNone/>
-            </a:pPr>
-            <a:r>
-              <a:rPr lang="en-US" sz="1400" i="1" dirty="0">
-                <a:solidFill>
                   <a:schemeClr val="accent3"/>
                 </a:solidFill>
               </a:rPr>
-              <a:t>Fig. 1. MONK 1 and 2, median trial: MSE (left), accuracy (right); training solid, test dashed.</a:t>
+              <a:t>Fig. 2. Trial with median TS accuracy; training solid, test dashed.</a:t>
             </a:r>
             <a:endParaRPr lang="en-US" sz="1400" dirty="0"/>
           </a:p>
@@ -19354,16 +19414,40 @@
           </a:p>
         </p:txBody>
       </p:sp>
-      <p:sp>
-        <p:nvSpPr>
-          <p:cNvPr id="3" name="Text 1"/>
+      <p:pic>
+        <p:nvPicPr>
+          <p:cNvPr id="3" name="Image 0" descr="MONK 3 learning curves: MSE and accuracy">    </p:cNvPr>
+          <p:cNvPicPr>
+            <a:picLocks noChangeAspect="1"/>
+          </p:cNvPicPr>
+          <p:nvPr/>
+        </p:nvPicPr>
+        <p:blipFill>
+          <a:blip r:embed="rId1"/>
+          <a:stretch>
+            <a:fillRect/>
+          </a:stretch>
+        </p:blipFill>
+        <p:spPr>
+          <a:xfrm>
+            <a:off x="457200" y="960120"/>
+            <a:ext cx="5120640" cy="1691363"/>
+          </a:xfrm>
+          <a:prstGeom prst="rect">
+            <a:avLst/>
+          </a:prstGeom>
+        </p:spPr>
+      </p:pic>
+      <p:sp>
+        <p:nvSpPr>
+          <p:cNvPr id="4" name="Text 1"/>
           <p:cNvSpPr txBox="1"/>
           <p:nvPr/>
         </p:nvSpPr>
         <p:spPr>
           <a:xfrm>
-            <a:off x="457200" y="960120"/>
-            <a:ext cx="1188720" cy="1508760"/>
+            <a:off x="5806440" y="960120"/>
+            <a:ext cx="2880360" cy="1691363"/>
           </a:xfrm>
           <a:prstGeom prst="rect">
             <a:avLst/>
@@ -19376,6 +19460,9 @@
           <a:lstStyle/>
           <a:p>
             <a:pPr indent="0" marL="0">
+              <a:spcAft>
+                <a:spcPts val="400"/>
+              </a:spcAft>
               <a:buNone/>
             </a:pPr>
             <a:r>
@@ -19388,43 +19475,73 @@
             </a:r>
             <a:endParaRPr lang="en-US" sz="1400" dirty="0"/>
           </a:p>
+          <a:p>
+            <a:pPr indent="0" marL="0">
+              <a:spcAft>
+                <a:spcPts val="600"/>
+              </a:spcAft>
+              <a:buNone/>
+            </a:pPr>
+            <a:r>
+              <a:rPr lang="en-US" sz="1400" dirty="0">
+                <a:solidFill>
+                  <a:schemeClr val="tx1"/>
+                </a:solidFill>
+              </a:rPr>
+              <a:t>TS 95.8% above TR 94.9%: 5% of the training labels are noisy [2]</a:t>
+            </a:r>
+            <a:endParaRPr lang="en-US" sz="1400" dirty="0"/>
+          </a:p>
+          <a:p>
+            <a:pPr indent="0" marL="0">
+              <a:buNone/>
+            </a:pPr>
+            <a:r>
+              <a:rPr lang="en-US" sz="1400" i="1" dirty="0">
+                <a:solidFill>
+                  <a:schemeClr val="accent3"/>
+                </a:solidFill>
+              </a:rPr>
+              <a:t>Fig. 3. Trial with median TS accuracy; training solid, test dashed.</a:t>
+            </a:r>
+            <a:endParaRPr lang="en-US" sz="1400" dirty="0"/>
+          </a:p>
         </p:txBody>
       </p:sp>
-      <p:sp>
-        <p:nvSpPr>
-          <p:cNvPr id="4" name="figure placeholder"/>
-          <p:cNvSpPr/>
+      <p:pic>
+        <p:nvPicPr>
+          <p:cNvPr id="5" name="Image 1" descr="MONK 3 (reg.) learning curves: MSE and accuracy">    </p:cNvPr>
+          <p:cNvPicPr>
+            <a:picLocks noChangeAspect="1"/>
+          </p:cNvPicPr>
           <p:nvPr/>
-        </p:nvSpPr>
-        <p:spPr>
-          <a:xfrm>
-            <a:off x="1737360" y="960120"/>
-            <a:ext cx="6949440" cy="1508760"/>
+        </p:nvPicPr>
+        <p:blipFill>
+          <a:blip r:embed="rId2"/>
+          <a:stretch>
+            <a:fillRect/>
+          </a:stretch>
+        </p:blipFill>
+        <p:spPr>
+          <a:xfrm>
+            <a:off x="457200" y="2834640"/>
+            <a:ext cx="5120640" cy="1691363"/>
           </a:xfrm>
           <a:prstGeom prst="rect">
             <a:avLst/>
           </a:prstGeom>
-          <a:solidFill>
-            <a:schemeClr val="bg1"/>
-          </a:solidFill>
-          <a:ln w="15875">
-            <a:solidFill>
-              <a:srgbClr val="9DB0C6"/>
-            </a:solidFill>
-            <a:prstDash val="dash"/>
-          </a:ln>
-        </p:spPr>
-      </p:sp>
-      <p:sp>
-        <p:nvSpPr>
-          <p:cNvPr id="5" name="Text 3"/>
+        </p:spPr>
+      </p:pic>
+      <p:sp>
+        <p:nvSpPr>
+          <p:cNvPr id="6" name="Text 2"/>
           <p:cNvSpPr txBox="1"/>
           <p:nvPr/>
         </p:nvSpPr>
         <p:spPr>
           <a:xfrm>
-            <a:off x="1920240" y="960120"/>
-            <a:ext cx="6583680" cy="1508760"/>
+            <a:off x="5806440" y="2834640"/>
+            <a:ext cx="2880360" cy="1691363"/>
           </a:xfrm>
           <a:prstGeom prst="rect">
             <a:avLst/>
@@ -19436,149 +19553,50 @@
           <a:bodyPr wrap="square" lIns="635" tIns="635" rIns="635" bIns="635" rtlCol="0" anchor="ctr"/>
           <a:lstStyle/>
           <a:p>
-            <a:pPr algn="ctr" indent="0" marL="0">
+            <a:pPr indent="0" marL="0">
+              <a:spcAft>
+                <a:spcPts val="400"/>
+              </a:spcAft>
+              <a:buNone/>
+            </a:pPr>
+            <a:r>
+              <a:rPr lang="en-US" sz="1600" b="1" dirty="0">
+                <a:solidFill>
+                  <a:schemeClr val="tx2"/>
+                </a:solidFill>
+              </a:rPr>
+              <a:t>MONK 3 (reg.)</a:t>
+            </a:r>
+            <a:endParaRPr lang="en-US" sz="1400" dirty="0"/>
+          </a:p>
+          <a:p>
+            <a:pPr indent="0" marL="0">
+              <a:spcAft>
+                <a:spcPts val="600"/>
+              </a:spcAft>
+              <a:buNone/>
+            </a:pPr>
+            <a:r>
+              <a:rPr lang="en-US" sz="1400" dirty="0">
+                <a:solidFill>
+                  <a:schemeClr val="tx1"/>
+                </a:solidFill>
+              </a:rPr>
+              <a:t>TS 97.1 ± 0.3%, TR 93.4%: L2 (λ 0.01) stops the fit of the noisy labels</a:t>
+            </a:r>
+            <a:endParaRPr lang="en-US" sz="1400" dirty="0"/>
+          </a:p>
+          <a:p>
+            <a:pPr indent="0" marL="0">
               <a:buNone/>
             </a:pPr>
             <a:r>
               <a:rPr lang="en-US" sz="1400" i="1" dirty="0">
                 <a:solidFill>
-                  <a:schemeClr val="accent2"/>
-                </a:solidFill>
-              </a:rPr>
-              <a:t>[MONK 3 plot without regularization]</a:t>
-            </a:r>
-            <a:endParaRPr lang="en-US" sz="1400" dirty="0"/>
-          </a:p>
-        </p:txBody>
-      </p:sp>
-      <p:sp>
-        <p:nvSpPr>
-          <p:cNvPr id="6" name="Text 4"/>
-          <p:cNvSpPr txBox="1"/>
-          <p:nvPr/>
-        </p:nvSpPr>
-        <p:spPr>
-          <a:xfrm>
-            <a:off x="457200" y="2587752"/>
-            <a:ext cx="1188720" cy="1508760"/>
-          </a:xfrm>
-          <a:prstGeom prst="rect">
-            <a:avLst/>
-          </a:prstGeom>
-          <a:noFill/>
-          <a:ln/>
-        </p:spPr>
-        <p:txBody>
-          <a:bodyPr wrap="square" lIns="635" tIns="635" rIns="635" bIns="635" rtlCol="0" anchor="ctr"/>
-          <a:lstStyle/>
-          <a:p>
-            <a:pPr indent="0" marL="0">
-              <a:buNone/>
-            </a:pPr>
-            <a:r>
-              <a:rPr lang="en-US" sz="1600" b="1" dirty="0">
-                <a:solidFill>
-                  <a:schemeClr val="tx2"/>
-                </a:solidFill>
-              </a:rPr>
-              <a:t>MONK 3 (reg.)</a:t>
-            </a:r>
-            <a:endParaRPr lang="en-US" sz="1400" dirty="0"/>
-          </a:p>
-        </p:txBody>
-      </p:sp>
-      <p:sp>
-        <p:nvSpPr>
-          <p:cNvPr id="7" name="figure placeholder"/>
-          <p:cNvSpPr/>
-          <p:nvPr/>
-        </p:nvSpPr>
-        <p:spPr>
-          <a:xfrm>
-            <a:off x="1737360" y="2587752"/>
-            <a:ext cx="6949440" cy="1508760"/>
-          </a:xfrm>
-          <a:prstGeom prst="rect">
-            <a:avLst/>
-          </a:prstGeom>
-          <a:solidFill>
-            <a:schemeClr val="bg1"/>
-          </a:solidFill>
-          <a:ln w="15875">
-            <a:solidFill>
-              <a:srgbClr val="9DB0C6"/>
-            </a:solidFill>
-            <a:prstDash val="dash"/>
-          </a:ln>
-        </p:spPr>
-      </p:sp>
-      <p:sp>
-        <p:nvSpPr>
-          <p:cNvPr id="8" name="Text 6"/>
-          <p:cNvSpPr txBox="1"/>
-          <p:nvPr/>
-        </p:nvSpPr>
-        <p:spPr>
-          <a:xfrm>
-            <a:off x="1920240" y="2587752"/>
-            <a:ext cx="6583680" cy="1508760"/>
-          </a:xfrm>
-          <a:prstGeom prst="rect">
-            <a:avLst/>
-          </a:prstGeom>
-          <a:noFill/>
-          <a:ln/>
-        </p:spPr>
-        <p:txBody>
-          <a:bodyPr wrap="square" lIns="635" tIns="635" rIns="635" bIns="635" rtlCol="0" anchor="ctr"/>
-          <a:lstStyle/>
-          <a:p>
-            <a:pPr algn="ctr" indent="0" marL="0">
-              <a:buNone/>
-            </a:pPr>
-            <a:r>
-              <a:rPr lang="en-US" sz="1400" i="1" dirty="0">
-                <a:solidFill>
-                  <a:schemeClr val="accent2"/>
-                </a:solidFill>
-              </a:rPr>
-              <a:t>[MONK 3 plot with L2 regularization]</a:t>
-            </a:r>
-            <a:endParaRPr lang="en-US" sz="1400" dirty="0"/>
-          </a:p>
-        </p:txBody>
-      </p:sp>
-      <p:sp>
-        <p:nvSpPr>
-          <p:cNvPr id="9" name="Text 7"/>
-          <p:cNvSpPr txBox="1"/>
-          <p:nvPr/>
-        </p:nvSpPr>
-        <p:spPr>
-          <a:xfrm>
-            <a:off x="457200" y="4160520"/>
-            <a:ext cx="8229600" cy="502920"/>
-          </a:xfrm>
-          <a:prstGeom prst="rect">
-            <a:avLst/>
-          </a:prstGeom>
-          <a:noFill/>
-          <a:ln/>
-        </p:spPr>
-        <p:txBody>
-          <a:bodyPr wrap="square" lIns="635" tIns="635" rIns="635" bIns="635" rtlCol="0" anchor="t"/>
-          <a:lstStyle/>
-          <a:p>
-            <a:pPr indent="0" marL="0">
-              <a:buNone/>
-            </a:pPr>
-            <a:r>
-              <a:rPr lang="en-US" sz="1400" i="1" dirty="0">
-                <a:solidFill>
                   <a:schemeClr val="accent3"/>
                 </a:solidFill>
               </a:rPr>
-              <a:t>Fig. 2. MONK 3 without and with L2, median trial: MSE (left), accuracy (right); training solid, test dashed.</a:t>
+              <a:t>Fig. 4. As Fig. 3, with L2; stops at the CV TR-MSE target.</a:t>
             </a:r>
             <a:endParaRPr lang="en-US" sz="1400" dirty="0"/>
           </a:p>
@@ -19773,7 +19791,7 @@
         <p:spPr>
           <a:xfrm>
             <a:off x="457200" y="1901952"/>
-            <a:ext cx="1316736" cy="548640"/>
+            <a:ext cx="2194560" cy="548640"/>
           </a:xfrm>
           <a:prstGeom prst="rect">
             <a:avLst/>
@@ -19798,7 +19816,7 @@
         <p:spPr>
           <a:xfrm>
             <a:off x="457200" y="1901952"/>
-            <a:ext cx="1316736" cy="548640"/>
+            <a:ext cx="2194560" cy="548640"/>
           </a:xfrm>
           <a:prstGeom prst="rect">
             <a:avLst/>
@@ -19833,8 +19851,8 @@
         </p:nvSpPr>
         <p:spPr>
           <a:xfrm>
-            <a:off x="1773936" y="1901952"/>
-            <a:ext cx="1316736" cy="548640"/>
+            <a:off x="2651760" y="1901952"/>
+            <a:ext cx="2194560" cy="548640"/>
           </a:xfrm>
           <a:prstGeom prst="rect">
             <a:avLst/>
@@ -19858,8 +19876,8 @@
         </p:nvSpPr>
         <p:spPr>
           <a:xfrm>
-            <a:off x="1773936" y="1901952"/>
-            <a:ext cx="1316736" cy="548640"/>
+            <a:off x="2651760" y="1901952"/>
+            <a:ext cx="2194560" cy="548640"/>
           </a:xfrm>
           <a:prstGeom prst="rect">
             <a:avLst/>
@@ -19894,8 +19912,8 @@
         </p:nvSpPr>
         <p:spPr>
           <a:xfrm>
-            <a:off x="3090672" y="1901952"/>
-            <a:ext cx="1316736" cy="548640"/>
+            <a:off x="4846320" y="1901952"/>
+            <a:ext cx="2194560" cy="548640"/>
           </a:xfrm>
           <a:prstGeom prst="rect">
             <a:avLst/>
@@ -19919,8 +19937,8 @@
         </p:nvSpPr>
         <p:spPr>
           <a:xfrm>
-            <a:off x="3090672" y="1901952"/>
-            <a:ext cx="1316736" cy="548640"/>
+            <a:off x="4846320" y="1901952"/>
+            <a:ext cx="2194560" cy="548640"/>
           </a:xfrm>
           <a:prstGeom prst="rect">
             <a:avLst/>
@@ -19949,129 +19967,7 @@
       </p:sp>
       <p:sp>
         <p:nvSpPr>
-          <p:cNvPr id="11" name="fold 4"/>
-          <p:cNvSpPr/>
-          <p:nvPr/>
-        </p:nvSpPr>
-        <p:spPr>
-          <a:xfrm>
-            <a:off x="4407408" y="1901952"/>
-            <a:ext cx="1316736" cy="548640"/>
-          </a:xfrm>
-          <a:prstGeom prst="rect">
-            <a:avLst/>
-          </a:prstGeom>
-          <a:solidFill>
-            <a:schemeClr val="bg2"/>
-          </a:solidFill>
-          <a:ln w="25400">
-            <a:solidFill>
-              <a:srgbClr val="FFFFFF"/>
-            </a:solidFill>
-            <a:prstDash val="solid"/>
-          </a:ln>
-        </p:spPr>
-      </p:sp>
-      <p:sp>
-        <p:nvSpPr>
-          <p:cNvPr id="12" name="Text 10"/>
-          <p:cNvSpPr txBox="1"/>
-          <p:nvPr/>
-        </p:nvSpPr>
-        <p:spPr>
-          <a:xfrm>
-            <a:off x="4407408" y="1901952"/>
-            <a:ext cx="1316736" cy="548640"/>
-          </a:xfrm>
-          <a:prstGeom prst="rect">
-            <a:avLst/>
-          </a:prstGeom>
-          <a:noFill/>
-          <a:ln/>
-        </p:spPr>
-        <p:txBody>
-          <a:bodyPr wrap="square" lIns="635" tIns="635" rIns="635" bIns="635" rtlCol="0" anchor="ctr"/>
-          <a:lstStyle/>
-          <a:p>
-            <a:pPr algn="ctr" indent="0" marL="0">
-              <a:buNone/>
-            </a:pPr>
-            <a:r>
-              <a:rPr lang="en-US" sz="1400" dirty="0">
-                <a:solidFill>
-                  <a:schemeClr val="tx1"/>
-                </a:solidFill>
-              </a:rPr>
-              <a:t>Fold 4</a:t>
-            </a:r>
-            <a:endParaRPr lang="en-US" sz="1400" dirty="0"/>
-          </a:p>
-        </p:txBody>
-      </p:sp>
-      <p:sp>
-        <p:nvSpPr>
-          <p:cNvPr id="13" name="fold 5"/>
-          <p:cNvSpPr/>
-          <p:nvPr/>
-        </p:nvSpPr>
-        <p:spPr>
-          <a:xfrm>
-            <a:off x="5724144" y="1901952"/>
-            <a:ext cx="1316736" cy="548640"/>
-          </a:xfrm>
-          <a:prstGeom prst="rect">
-            <a:avLst/>
-          </a:prstGeom>
-          <a:solidFill>
-            <a:schemeClr val="bg2"/>
-          </a:solidFill>
-          <a:ln w="25400">
-            <a:solidFill>
-              <a:srgbClr val="FFFFFF"/>
-            </a:solidFill>
-            <a:prstDash val="solid"/>
-          </a:ln>
-        </p:spPr>
-      </p:sp>
-      <p:sp>
-        <p:nvSpPr>
-          <p:cNvPr id="14" name="Text 12"/>
-          <p:cNvSpPr txBox="1"/>
-          <p:nvPr/>
-        </p:nvSpPr>
-        <p:spPr>
-          <a:xfrm>
-            <a:off x="5724144" y="1901952"/>
-            <a:ext cx="1316736" cy="548640"/>
-          </a:xfrm>
-          <a:prstGeom prst="rect">
-            <a:avLst/>
-          </a:prstGeom>
-          <a:noFill/>
-          <a:ln/>
-        </p:spPr>
-        <p:txBody>
-          <a:bodyPr wrap="square" lIns="635" tIns="635" rIns="635" bIns="635" rtlCol="0" anchor="ctr"/>
-          <a:lstStyle/>
-          <a:p>
-            <a:pPr algn="ctr" indent="0" marL="0">
-              <a:buNone/>
-            </a:pPr>
-            <a:r>
-              <a:rPr lang="en-US" sz="1400" dirty="0">
-                <a:solidFill>
-                  <a:schemeClr val="tx1"/>
-                </a:solidFill>
-              </a:rPr>
-              <a:t>Fold 5</a:t>
-            </a:r>
-            <a:endParaRPr lang="en-US" sz="1400" dirty="0"/>
-          </a:p>
-        </p:txBody>
-      </p:sp>
-      <p:sp>
-        <p:nvSpPr>
-          <p:cNvPr id="15" name="internal test"/>
+          <p:cNvPr id="11" name="internal test"/>
           <p:cNvSpPr/>
           <p:nvPr/>
         </p:nvSpPr>
@@ -20096,7 +19992,7 @@
       </p:sp>
       <p:sp>
         <p:nvSpPr>
-          <p:cNvPr id="16" name="Text 14"/>
+          <p:cNvPr id="12" name="Text 10"/>
           <p:cNvSpPr txBox="1"/>
           <p:nvPr/>
         </p:nvSpPr>
@@ -20132,7 +20028,7 @@
       </p:sp>
       <p:sp>
         <p:nvSpPr>
-          <p:cNvPr id="17" name="Text 15"/>
+          <p:cNvPr id="13" name="Text 11"/>
           <p:cNvSpPr txBox="1"/>
           <p:nvPr/>
         </p:nvSpPr>
@@ -20166,12 +20062,23 @@
               <a:buNone/>
             </a:pPr>
             <a:r>
+              <a:rPr lang="en-US" sz="1400" i="1" dirty="0">
+                <a:solidFill>
+                  <a:schemeClr val="accent2"/>
+                </a:solidFill>
+              </a:rPr>
+              <a:t>3</a:t>
+            </a:r>
+            <a:pPr indent="0" marL="0">
+              <a:buNone/>
+            </a:pPr>
+            <a:r>
               <a:rPr lang="en-US" sz="1400" dirty="0">
                 <a:solidFill>
                   <a:schemeClr val="tx1"/>
                 </a:solidFill>
               </a:rPr>
-              <a:t>5-fold CV for model selection, TR 320 / VL 80 per fold, </a:t>
+              <a:t>-fold CV for model selection, TR ≈ 267 / VL ≈ 133 per fold, </a:t>
             </a:r>
             <a:pPr indent="0" marL="0">
               <a:buNone/>
@@ -20182,7 +20089,7 @@
                   <a:schemeClr val="accent2"/>
                 </a:solidFill>
               </a:rPr>
-              <a:t>[5]</a:t>
+              <a:t>10</a:t>
             </a:r>
             <a:pPr indent="0" marL="0">
               <a:buNone/>
@@ -20201,7 +20108,7 @@
       </p:sp>
       <p:sp>
         <p:nvSpPr>
-          <p:cNvPr id="18" name="Text 16"/>
+          <p:cNvPr id="14" name="Text 12"/>
           <p:cNvSpPr txBox="1"/>
           <p:nvPr/>
         </p:nvSpPr>
@@ -20248,7 +20155,7 @@
       </p:sp>
       <p:sp>
         <p:nvSpPr>
-          <p:cNvPr id="19" name="step 1"/>
+          <p:cNvPr id="15" name="step 1"/>
           <p:cNvSpPr/>
           <p:nvPr/>
         </p:nvSpPr>
@@ -20270,7 +20177,7 @@
       </p:sp>
       <p:sp>
         <p:nvSpPr>
-          <p:cNvPr id="20" name="Text 18"/>
+          <p:cNvPr id="16" name="Text 14"/>
           <p:cNvSpPr txBox="1"/>
           <p:nvPr/>
         </p:nvSpPr>
@@ -20317,7 +20224,7 @@
       </p:sp>
       <p:sp>
         <p:nvSpPr>
-          <p:cNvPr id="21" name="Shape 19"/>
+          <p:cNvPr id="17" name="Shape 15"/>
           <p:cNvSpPr/>
           <p:nvPr/>
         </p:nvSpPr>
@@ -20341,7 +20248,7 @@
       </p:sp>
       <p:sp>
         <p:nvSpPr>
-          <p:cNvPr id="22" name="step 2"/>
+          <p:cNvPr id="18" name="step 2"/>
           <p:cNvSpPr/>
           <p:nvPr/>
         </p:nvSpPr>
@@ -20363,7 +20270,7 @@
       </p:sp>
       <p:sp>
         <p:nvSpPr>
-          <p:cNvPr id="23" name="Text 21"/>
+          <p:cNvPr id="19" name="Text 17"/>
           <p:cNvSpPr txBox="1"/>
           <p:nvPr/>
         </p:nvSpPr>
@@ -20391,7 +20298,7 @@
                   <a:schemeClr val="tx1"/>
                 </a:solidFill>
               </a:rPr>
-              <a:t>Final retraining </a:t>
+              <a:t>Assessment: </a:t>
             </a:r>
             <a:pPr indent="0" marL="0">
               <a:buNone/>
@@ -20402,7 +20309,7 @@
                   <a:schemeClr val="tx1"/>
                 </a:solidFill>
               </a:rPr>
-              <a:t>of one network on the 400 design patterns, stopped at the CV TR-error target</a:t>
+              <a:t>30 retrainings on the 400 design patterns up to the CV TR-MEE target; TS used once</a:t>
             </a:r>
             <a:endParaRPr lang="en-US" sz="1400" dirty="0"/>
           </a:p>
@@ -20410,7 +20317,7 @@
       </p:sp>
       <p:sp>
         <p:nvSpPr>
-          <p:cNvPr id="24" name="Shape 22"/>
+          <p:cNvPr id="20" name="Shape 18"/>
           <p:cNvSpPr/>
           <p:nvPr/>
         </p:nvSpPr>
@@ -20434,7 +20341,7 @@
       </p:sp>
       <p:sp>
         <p:nvSpPr>
-          <p:cNvPr id="25" name="step 3"/>
+          <p:cNvPr id="21" name="step 3"/>
           <p:cNvSpPr/>
           <p:nvPr/>
         </p:nvSpPr>
@@ -20456,7 +20363,7 @@
       </p:sp>
       <p:sp>
         <p:nvSpPr>
-          <p:cNvPr id="26" name="Text 24"/>
+          <p:cNvPr id="22" name="Text 20"/>
           <p:cNvSpPr txBox="1"/>
           <p:nvPr/>
         </p:nvSpPr>
@@ -20484,7 +20391,7 @@
                   <a:schemeClr val="tx1"/>
                 </a:solidFill>
               </a:rPr>
-              <a:t>Assessment: </a:t>
+              <a:t>Final model: </a:t>
             </a:r>
             <a:pPr indent="0" marL="0">
               <a:buNone/>
@@ -20495,7 +20402,7 @@
                   <a:schemeClr val="tx1"/>
                 </a:solidFill>
               </a:rPr>
-              <a:t>internal test MEE, then blind test predictions (1000)</a:t>
+              <a:t>trial-0 seeds, retrained on all 500 patterns up to the same target → blind test</a:t>
             </a:r>
             <a:endParaRPr lang="en-US" sz="1400" dirty="0"/>
           </a:p>

</xml_diff>